<commit_message>
Add SyncJournal and Morani logos to every slide
Small footer with the app's SJ hexagon and the Morani badge on content
slides; SJ hexagon added to the title and closing slides.

Co-Authored-By: Claude Opus 5.5 <noreply@anthropic.com>
Claude-Session: https://claude.ai/code/session_0182EjoBH9S38qTYpVbaTvpP
</commit_message>
<xml_diff>
--- a/presentatie/syncjournal-live-event.pptx
+++ b/presentatie/syncjournal-live-event.pptx
@@ -4846,9 +4846,33 @@
           </a:p>
         </p:txBody>
       </p:sp>
-      <p:sp>
-        <p:nvSpPr>
-          <p:cNvPr id="3" name="TextBox 2"/>
+      <p:pic>
+        <p:nvPicPr>
+          <p:cNvPr id="3" name="Picture 2" descr="syncjournal-hex.png"/>
+          <p:cNvPicPr>
+            <a:picLocks noChangeAspect="1"/>
+          </p:cNvPicPr>
+          <p:nvPr/>
+        </p:nvPicPr>
+        <p:blipFill>
+          <a:blip r:embed="rId2"/>
+          <a:stretch>
+            <a:fillRect/>
+          </a:stretch>
+        </p:blipFill>
+        <p:spPr>
+          <a:xfrm>
+            <a:off x="1115568" y="1051560"/>
+            <a:ext cx="868680" cy="868680"/>
+          </a:xfrm>
+          <a:prstGeom prst="rect">
+            <a:avLst/>
+          </a:prstGeom>
+        </p:spPr>
+      </p:pic>
+      <p:sp>
+        <p:nvSpPr>
+          <p:cNvPr id="4" name="TextBox 3"/>
           <p:cNvSpPr txBox="1"/>
           <p:nvPr/>
         </p:nvSpPr>
@@ -4892,7 +4916,7 @@
       </p:sp>
       <p:sp>
         <p:nvSpPr>
-          <p:cNvPr id="4" name="TextBox 3"/>
+          <p:cNvPr id="5" name="TextBox 4"/>
           <p:cNvSpPr txBox="1"/>
           <p:nvPr/>
         </p:nvSpPr>
@@ -4927,7 +4951,7 @@
       </p:sp>
       <p:sp>
         <p:nvSpPr>
-          <p:cNvPr id="5" name="Rounded Rectangle 4"/>
+          <p:cNvPr id="6" name="Rounded Rectangle 5"/>
           <p:cNvSpPr/>
           <p:nvPr/>
         </p:nvSpPr>
@@ -4973,7 +4997,7 @@
       </p:sp>
       <p:sp>
         <p:nvSpPr>
-          <p:cNvPr id="6" name="TextBox 5"/>
+          <p:cNvPr id="7" name="TextBox 6"/>
           <p:cNvSpPr txBox="1"/>
           <p:nvPr/>
         </p:nvSpPr>
@@ -5008,14 +5032,14 @@
       </p:sp>
       <p:pic>
         <p:nvPicPr>
-          <p:cNvPr id="7" name="Picture 6" descr="morani-badge.png"/>
+          <p:cNvPr id="8" name="Picture 7" descr="morani-badge.png"/>
           <p:cNvPicPr>
             <a:picLocks noChangeAspect="1"/>
           </p:cNvPicPr>
           <p:nvPr/>
         </p:nvPicPr>
         <p:blipFill>
-          <a:blip r:embed="rId2"/>
+          <a:blip r:embed="rId3"/>
           <a:stretch>
             <a:fillRect/>
           </a:stretch>
@@ -5032,7 +5056,7 @@
       </p:pic>
       <p:sp>
         <p:nvSpPr>
-          <p:cNvPr id="8" name="TextBox 7"/>
+          <p:cNvPr id="9" name="TextBox 8"/>
           <p:cNvSpPr txBox="1"/>
           <p:nvPr/>
         </p:nvSpPr>
@@ -5172,9 +5196,57 @@
           </a:p>
         </p:txBody>
       </p:sp>
-      <p:sp>
-        <p:nvSpPr>
-          <p:cNvPr id="4" name="Rounded Rectangle 3"/>
+      <p:pic>
+        <p:nvPicPr>
+          <p:cNvPr id="4" name="Picture 3" descr="syncjournal-hex.png"/>
+          <p:cNvPicPr>
+            <a:picLocks noChangeAspect="1"/>
+          </p:cNvPicPr>
+          <p:nvPr/>
+        </p:nvPicPr>
+        <p:blipFill>
+          <a:blip r:embed="rId2"/>
+          <a:stretch>
+            <a:fillRect/>
+          </a:stretch>
+        </p:blipFill>
+        <p:spPr>
+          <a:xfrm>
+            <a:off x="10259568" y="6382512"/>
+            <a:ext cx="347472" cy="347472"/>
+          </a:xfrm>
+          <a:prstGeom prst="rect">
+            <a:avLst/>
+          </a:prstGeom>
+        </p:spPr>
+      </p:pic>
+      <p:pic>
+        <p:nvPicPr>
+          <p:cNvPr id="5" name="Picture 4" descr="morani-badge.png"/>
+          <p:cNvPicPr>
+            <a:picLocks noChangeAspect="1"/>
+          </p:cNvPicPr>
+          <p:nvPr/>
+        </p:nvPicPr>
+        <p:blipFill>
+          <a:blip r:embed="rId3"/>
+          <a:stretch>
+            <a:fillRect/>
+          </a:stretch>
+        </p:blipFill>
+        <p:spPr>
+          <a:xfrm>
+            <a:off x="10698480" y="6400800"/>
+            <a:ext cx="799447" cy="310896"/>
+          </a:xfrm>
+          <a:prstGeom prst="rect">
+            <a:avLst/>
+          </a:prstGeom>
+        </p:spPr>
+      </p:pic>
+      <p:sp>
+        <p:nvSpPr>
+          <p:cNvPr id="6" name="Rounded Rectangle 5"/>
           <p:cNvSpPr/>
           <p:nvPr/>
         </p:nvSpPr>
@@ -5220,7 +5292,7 @@
       </p:sp>
       <p:sp>
         <p:nvSpPr>
-          <p:cNvPr id="5" name="TextBox 4"/>
+          <p:cNvPr id="7" name="TextBox 6"/>
           <p:cNvSpPr txBox="1"/>
           <p:nvPr/>
         </p:nvSpPr>
@@ -5255,14 +5327,14 @@
       </p:sp>
       <p:sp>
         <p:nvSpPr>
-          <p:cNvPr id="6" name="Rounded Rectangle 5"/>
+          <p:cNvPr id="8" name="Rounded Rectangle 7"/>
           <p:cNvSpPr/>
           <p:nvPr/>
         </p:nvSpPr>
         <p:spPr>
           <a:xfrm>
             <a:off x="731520" y="1874519"/>
-            <a:ext cx="10725912" cy="3602736"/>
+            <a:ext cx="10725912" cy="3383280"/>
           </a:xfrm>
           <a:prstGeom prst="roundRect">
             <a:avLst>
@@ -5303,13 +5375,13 @@
       </p:sp>
       <p:sp>
         <p:nvSpPr>
-          <p:cNvPr id="7" name="Rounded Rectangle 6"/>
+          <p:cNvPr id="9" name="Rounded Rectangle 8"/>
           <p:cNvSpPr/>
           <p:nvPr/>
         </p:nvSpPr>
         <p:spPr>
           <a:xfrm>
-            <a:off x="1143000" y="2423160"/>
+            <a:off x="1143000" y="2395727"/>
             <a:ext cx="146304" cy="146304"/>
           </a:xfrm>
           <a:prstGeom prst="roundRect">
@@ -5349,14 +5421,14 @@
       </p:sp>
       <p:sp>
         <p:nvSpPr>
-          <p:cNvPr id="8" name="TextBox 7"/>
+          <p:cNvPr id="10" name="TextBox 9"/>
           <p:cNvSpPr txBox="1"/>
           <p:nvPr/>
         </p:nvSpPr>
         <p:spPr>
           <a:xfrm>
             <a:off x="1508760" y="2103120"/>
-            <a:ext cx="9628632" cy="786384"/>
+            <a:ext cx="9628632" cy="731520"/>
           </a:xfrm>
           <a:prstGeom prst="rect">
             <a:avLst/>
@@ -5384,13 +5456,13 @@
       </p:sp>
       <p:sp>
         <p:nvSpPr>
-          <p:cNvPr id="9" name="Rounded Rectangle 8"/>
+          <p:cNvPr id="11" name="Rounded Rectangle 10"/>
           <p:cNvSpPr/>
           <p:nvPr/>
         </p:nvSpPr>
         <p:spPr>
           <a:xfrm>
-            <a:off x="1143000" y="3209544"/>
+            <a:off x="1143000" y="3127247"/>
             <a:ext cx="146304" cy="146304"/>
           </a:xfrm>
           <a:prstGeom prst="roundRect">
@@ -5430,14 +5502,14 @@
       </p:sp>
       <p:sp>
         <p:nvSpPr>
-          <p:cNvPr id="10" name="TextBox 9"/>
+          <p:cNvPr id="12" name="TextBox 11"/>
           <p:cNvSpPr txBox="1"/>
           <p:nvPr/>
         </p:nvSpPr>
         <p:spPr>
           <a:xfrm>
-            <a:off x="1508760" y="2889503"/>
-            <a:ext cx="9628632" cy="786384"/>
+            <a:off x="1508760" y="2834639"/>
+            <a:ext cx="9628632" cy="731520"/>
           </a:xfrm>
           <a:prstGeom prst="rect">
             <a:avLst/>
@@ -5465,13 +5537,13 @@
       </p:sp>
       <p:sp>
         <p:nvSpPr>
-          <p:cNvPr id="11" name="Rounded Rectangle 10"/>
+          <p:cNvPr id="13" name="Rounded Rectangle 12"/>
           <p:cNvSpPr/>
           <p:nvPr/>
         </p:nvSpPr>
         <p:spPr>
           <a:xfrm>
-            <a:off x="1143000" y="3995927"/>
+            <a:off x="1143000" y="3858768"/>
             <a:ext cx="146304" cy="146304"/>
           </a:xfrm>
           <a:prstGeom prst="roundRect">
@@ -5511,14 +5583,14 @@
       </p:sp>
       <p:sp>
         <p:nvSpPr>
-          <p:cNvPr id="12" name="TextBox 11"/>
+          <p:cNvPr id="14" name="TextBox 13"/>
           <p:cNvSpPr txBox="1"/>
           <p:nvPr/>
         </p:nvSpPr>
         <p:spPr>
           <a:xfrm>
-            <a:off x="1508760" y="3675887"/>
-            <a:ext cx="9628632" cy="786384"/>
+            <a:off x="1508760" y="3566160"/>
+            <a:ext cx="9628632" cy="731520"/>
           </a:xfrm>
           <a:prstGeom prst="rect">
             <a:avLst/>
@@ -5546,13 +5618,13 @@
       </p:sp>
       <p:sp>
         <p:nvSpPr>
-          <p:cNvPr id="13" name="Rounded Rectangle 12"/>
+          <p:cNvPr id="15" name="Rounded Rectangle 14"/>
           <p:cNvSpPr/>
           <p:nvPr/>
         </p:nvSpPr>
         <p:spPr>
           <a:xfrm>
-            <a:off x="1143000" y="4782312"/>
+            <a:off x="1143000" y="4590288"/>
             <a:ext cx="146304" cy="146304"/>
           </a:xfrm>
           <a:prstGeom prst="roundRect">
@@ -5592,14 +5664,14 @@
       </p:sp>
       <p:sp>
         <p:nvSpPr>
-          <p:cNvPr id="14" name="TextBox 13"/>
+          <p:cNvPr id="16" name="TextBox 15"/>
           <p:cNvSpPr txBox="1"/>
           <p:nvPr/>
         </p:nvSpPr>
         <p:spPr>
           <a:xfrm>
-            <a:off x="1508760" y="4462272"/>
-            <a:ext cx="9628632" cy="786384"/>
+            <a:off x="1508760" y="4297680"/>
+            <a:ext cx="9628632" cy="731520"/>
           </a:xfrm>
           <a:prstGeom prst="rect">
             <a:avLst/>
@@ -5732,9 +5804,57 @@
           </a:p>
         </p:txBody>
       </p:sp>
-      <p:sp>
-        <p:nvSpPr>
-          <p:cNvPr id="4" name="Rounded Rectangle 3"/>
+      <p:pic>
+        <p:nvPicPr>
+          <p:cNvPr id="4" name="Picture 3" descr="syncjournal-hex.png"/>
+          <p:cNvPicPr>
+            <a:picLocks noChangeAspect="1"/>
+          </p:cNvPicPr>
+          <p:nvPr/>
+        </p:nvPicPr>
+        <p:blipFill>
+          <a:blip r:embed="rId2"/>
+          <a:stretch>
+            <a:fillRect/>
+          </a:stretch>
+        </p:blipFill>
+        <p:spPr>
+          <a:xfrm>
+            <a:off x="10259568" y="6382512"/>
+            <a:ext cx="347472" cy="347472"/>
+          </a:xfrm>
+          <a:prstGeom prst="rect">
+            <a:avLst/>
+          </a:prstGeom>
+        </p:spPr>
+      </p:pic>
+      <p:pic>
+        <p:nvPicPr>
+          <p:cNvPr id="5" name="Picture 4" descr="morani-badge.png"/>
+          <p:cNvPicPr>
+            <a:picLocks noChangeAspect="1"/>
+          </p:cNvPicPr>
+          <p:nvPr/>
+        </p:nvPicPr>
+        <p:blipFill>
+          <a:blip r:embed="rId3"/>
+          <a:stretch>
+            <a:fillRect/>
+          </a:stretch>
+        </p:blipFill>
+        <p:spPr>
+          <a:xfrm>
+            <a:off x="10698480" y="6400800"/>
+            <a:ext cx="799447" cy="310896"/>
+          </a:xfrm>
+          <a:prstGeom prst="rect">
+            <a:avLst/>
+          </a:prstGeom>
+        </p:spPr>
+      </p:pic>
+      <p:sp>
+        <p:nvSpPr>
+          <p:cNvPr id="6" name="Rounded Rectangle 5"/>
           <p:cNvSpPr/>
           <p:nvPr/>
         </p:nvSpPr>
@@ -5780,7 +5900,7 @@
       </p:sp>
       <p:sp>
         <p:nvSpPr>
-          <p:cNvPr id="5" name="TextBox 4"/>
+          <p:cNvPr id="7" name="TextBox 6"/>
           <p:cNvSpPr txBox="1"/>
           <p:nvPr/>
         </p:nvSpPr>
@@ -5815,14 +5935,14 @@
       </p:sp>
       <p:sp>
         <p:nvSpPr>
-          <p:cNvPr id="6" name="Rounded Rectangle 5"/>
+          <p:cNvPr id="8" name="Rounded Rectangle 7"/>
           <p:cNvSpPr/>
           <p:nvPr/>
         </p:nvSpPr>
         <p:spPr>
           <a:xfrm>
             <a:off x="731520" y="1874519"/>
-            <a:ext cx="10725912" cy="4389120"/>
+            <a:ext cx="10725912" cy="4114800"/>
           </a:xfrm>
           <a:prstGeom prst="roundRect">
             <a:avLst>
@@ -5863,13 +5983,13 @@
       </p:sp>
       <p:sp>
         <p:nvSpPr>
-          <p:cNvPr id="7" name="Rounded Rectangle 6"/>
+          <p:cNvPr id="9" name="Rounded Rectangle 8"/>
           <p:cNvSpPr/>
           <p:nvPr/>
         </p:nvSpPr>
         <p:spPr>
           <a:xfrm>
-            <a:off x="1143000" y="2423160"/>
+            <a:off x="1143000" y="2395727"/>
             <a:ext cx="146304" cy="146304"/>
           </a:xfrm>
           <a:prstGeom prst="roundRect">
@@ -5909,14 +6029,14 @@
       </p:sp>
       <p:sp>
         <p:nvSpPr>
-          <p:cNvPr id="8" name="TextBox 7"/>
+          <p:cNvPr id="10" name="TextBox 9"/>
           <p:cNvSpPr txBox="1"/>
           <p:nvPr/>
         </p:nvSpPr>
         <p:spPr>
           <a:xfrm>
             <a:off x="1508760" y="2103120"/>
-            <a:ext cx="9628632" cy="786384"/>
+            <a:ext cx="9628632" cy="731520"/>
           </a:xfrm>
           <a:prstGeom prst="rect">
             <a:avLst/>
@@ -5944,13 +6064,13 @@
       </p:sp>
       <p:sp>
         <p:nvSpPr>
-          <p:cNvPr id="9" name="Rounded Rectangle 8"/>
+          <p:cNvPr id="11" name="Rounded Rectangle 10"/>
           <p:cNvSpPr/>
           <p:nvPr/>
         </p:nvSpPr>
         <p:spPr>
           <a:xfrm>
-            <a:off x="1143000" y="3209544"/>
+            <a:off x="1143000" y="3127247"/>
             <a:ext cx="146304" cy="146304"/>
           </a:xfrm>
           <a:prstGeom prst="roundRect">
@@ -5990,14 +6110,14 @@
       </p:sp>
       <p:sp>
         <p:nvSpPr>
-          <p:cNvPr id="10" name="TextBox 9"/>
+          <p:cNvPr id="12" name="TextBox 11"/>
           <p:cNvSpPr txBox="1"/>
           <p:nvPr/>
         </p:nvSpPr>
         <p:spPr>
           <a:xfrm>
-            <a:off x="1508760" y="2889503"/>
-            <a:ext cx="9628632" cy="786384"/>
+            <a:off x="1508760" y="2834639"/>
+            <a:ext cx="9628632" cy="731520"/>
           </a:xfrm>
           <a:prstGeom prst="rect">
             <a:avLst/>
@@ -6025,13 +6145,13 @@
       </p:sp>
       <p:sp>
         <p:nvSpPr>
-          <p:cNvPr id="11" name="Rounded Rectangle 10"/>
+          <p:cNvPr id="13" name="Rounded Rectangle 12"/>
           <p:cNvSpPr/>
           <p:nvPr/>
         </p:nvSpPr>
         <p:spPr>
           <a:xfrm>
-            <a:off x="1143000" y="3995927"/>
+            <a:off x="1143000" y="3858768"/>
             <a:ext cx="146304" cy="146304"/>
           </a:xfrm>
           <a:prstGeom prst="roundRect">
@@ -6071,14 +6191,14 @@
       </p:sp>
       <p:sp>
         <p:nvSpPr>
-          <p:cNvPr id="12" name="TextBox 11"/>
+          <p:cNvPr id="14" name="TextBox 13"/>
           <p:cNvSpPr txBox="1"/>
           <p:nvPr/>
         </p:nvSpPr>
         <p:spPr>
           <a:xfrm>
-            <a:off x="1508760" y="3675887"/>
-            <a:ext cx="9628632" cy="786384"/>
+            <a:off x="1508760" y="3566160"/>
+            <a:ext cx="9628632" cy="731520"/>
           </a:xfrm>
           <a:prstGeom prst="rect">
             <a:avLst/>
@@ -6106,13 +6226,13 @@
       </p:sp>
       <p:sp>
         <p:nvSpPr>
-          <p:cNvPr id="13" name="Rounded Rectangle 12"/>
+          <p:cNvPr id="15" name="Rounded Rectangle 14"/>
           <p:cNvSpPr/>
           <p:nvPr/>
         </p:nvSpPr>
         <p:spPr>
           <a:xfrm>
-            <a:off x="1143000" y="4782312"/>
+            <a:off x="1143000" y="4590288"/>
             <a:ext cx="146304" cy="146304"/>
           </a:xfrm>
           <a:prstGeom prst="roundRect">
@@ -6152,14 +6272,14 @@
       </p:sp>
       <p:sp>
         <p:nvSpPr>
-          <p:cNvPr id="14" name="TextBox 13"/>
+          <p:cNvPr id="16" name="TextBox 15"/>
           <p:cNvSpPr txBox="1"/>
           <p:nvPr/>
         </p:nvSpPr>
         <p:spPr>
           <a:xfrm>
-            <a:off x="1508760" y="4462272"/>
-            <a:ext cx="9628632" cy="786384"/>
+            <a:off x="1508760" y="4297680"/>
+            <a:ext cx="9628632" cy="731520"/>
           </a:xfrm>
           <a:prstGeom prst="rect">
             <a:avLst/>
@@ -6187,13 +6307,13 @@
       </p:sp>
       <p:sp>
         <p:nvSpPr>
-          <p:cNvPr id="15" name="Rounded Rectangle 14"/>
+          <p:cNvPr id="17" name="Rounded Rectangle 16"/>
           <p:cNvSpPr/>
           <p:nvPr/>
         </p:nvSpPr>
         <p:spPr>
           <a:xfrm>
-            <a:off x="1143000" y="5568696"/>
+            <a:off x="1143000" y="5321808"/>
             <a:ext cx="146304" cy="146304"/>
           </a:xfrm>
           <a:prstGeom prst="roundRect">
@@ -6233,14 +6353,14 @@
       </p:sp>
       <p:sp>
         <p:nvSpPr>
-          <p:cNvPr id="16" name="TextBox 15"/>
+          <p:cNvPr id="18" name="TextBox 17"/>
           <p:cNvSpPr txBox="1"/>
           <p:nvPr/>
         </p:nvSpPr>
         <p:spPr>
           <a:xfrm>
-            <a:off x="1508760" y="5248656"/>
-            <a:ext cx="9628632" cy="786384"/>
+            <a:off x="1508760" y="5029200"/>
+            <a:ext cx="9628632" cy="731520"/>
           </a:xfrm>
           <a:prstGeom prst="rect">
             <a:avLst/>
@@ -6373,9 +6493,57 @@
           </a:p>
         </p:txBody>
       </p:sp>
-      <p:sp>
-        <p:nvSpPr>
-          <p:cNvPr id="4" name="Rounded Rectangle 3"/>
+      <p:pic>
+        <p:nvPicPr>
+          <p:cNvPr id="4" name="Picture 3" descr="syncjournal-hex.png"/>
+          <p:cNvPicPr>
+            <a:picLocks noChangeAspect="1"/>
+          </p:cNvPicPr>
+          <p:nvPr/>
+        </p:nvPicPr>
+        <p:blipFill>
+          <a:blip r:embed="rId2"/>
+          <a:stretch>
+            <a:fillRect/>
+          </a:stretch>
+        </p:blipFill>
+        <p:spPr>
+          <a:xfrm>
+            <a:off x="10259568" y="6382512"/>
+            <a:ext cx="347472" cy="347472"/>
+          </a:xfrm>
+          <a:prstGeom prst="rect">
+            <a:avLst/>
+          </a:prstGeom>
+        </p:spPr>
+      </p:pic>
+      <p:pic>
+        <p:nvPicPr>
+          <p:cNvPr id="5" name="Picture 4" descr="morani-badge.png"/>
+          <p:cNvPicPr>
+            <a:picLocks noChangeAspect="1"/>
+          </p:cNvPicPr>
+          <p:nvPr/>
+        </p:nvPicPr>
+        <p:blipFill>
+          <a:blip r:embed="rId3"/>
+          <a:stretch>
+            <a:fillRect/>
+          </a:stretch>
+        </p:blipFill>
+        <p:spPr>
+          <a:xfrm>
+            <a:off x="10698480" y="6400800"/>
+            <a:ext cx="799447" cy="310896"/>
+          </a:xfrm>
+          <a:prstGeom prst="rect">
+            <a:avLst/>
+          </a:prstGeom>
+        </p:spPr>
+      </p:pic>
+      <p:sp>
+        <p:nvSpPr>
+          <p:cNvPr id="6" name="Rounded Rectangle 5"/>
           <p:cNvSpPr/>
           <p:nvPr/>
         </p:nvSpPr>
@@ -6421,7 +6589,7 @@
       </p:sp>
       <p:sp>
         <p:nvSpPr>
-          <p:cNvPr id="5" name="TextBox 4"/>
+          <p:cNvPr id="7" name="TextBox 6"/>
           <p:cNvSpPr txBox="1"/>
           <p:nvPr/>
         </p:nvSpPr>
@@ -6456,14 +6624,14 @@
       </p:sp>
       <p:sp>
         <p:nvSpPr>
-          <p:cNvPr id="6" name="Rounded Rectangle 5"/>
+          <p:cNvPr id="8" name="Rounded Rectangle 7"/>
           <p:cNvSpPr/>
           <p:nvPr/>
         </p:nvSpPr>
         <p:spPr>
           <a:xfrm>
             <a:off x="731520" y="1874519"/>
-            <a:ext cx="10725912" cy="4389120"/>
+            <a:ext cx="10725912" cy="4114800"/>
           </a:xfrm>
           <a:prstGeom prst="roundRect">
             <a:avLst>
@@ -6504,13 +6672,13 @@
       </p:sp>
       <p:sp>
         <p:nvSpPr>
-          <p:cNvPr id="7" name="Rounded Rectangle 6"/>
+          <p:cNvPr id="9" name="Rounded Rectangle 8"/>
           <p:cNvSpPr/>
           <p:nvPr/>
         </p:nvSpPr>
         <p:spPr>
           <a:xfrm>
-            <a:off x="1143000" y="2423160"/>
+            <a:off x="1143000" y="2395727"/>
             <a:ext cx="146304" cy="146304"/>
           </a:xfrm>
           <a:prstGeom prst="roundRect">
@@ -6550,14 +6718,14 @@
       </p:sp>
       <p:sp>
         <p:nvSpPr>
-          <p:cNvPr id="8" name="TextBox 7"/>
+          <p:cNvPr id="10" name="TextBox 9"/>
           <p:cNvSpPr txBox="1"/>
           <p:nvPr/>
         </p:nvSpPr>
         <p:spPr>
           <a:xfrm>
             <a:off x="1508760" y="2103120"/>
-            <a:ext cx="9628632" cy="786384"/>
+            <a:ext cx="9628632" cy="731520"/>
           </a:xfrm>
           <a:prstGeom prst="rect">
             <a:avLst/>
@@ -6585,13 +6753,13 @@
       </p:sp>
       <p:sp>
         <p:nvSpPr>
-          <p:cNvPr id="9" name="Rounded Rectangle 8"/>
+          <p:cNvPr id="11" name="Rounded Rectangle 10"/>
           <p:cNvSpPr/>
           <p:nvPr/>
         </p:nvSpPr>
         <p:spPr>
           <a:xfrm>
-            <a:off x="1143000" y="3209544"/>
+            <a:off x="1143000" y="3127247"/>
             <a:ext cx="146304" cy="146304"/>
           </a:xfrm>
           <a:prstGeom prst="roundRect">
@@ -6631,14 +6799,14 @@
       </p:sp>
       <p:sp>
         <p:nvSpPr>
-          <p:cNvPr id="10" name="TextBox 9"/>
+          <p:cNvPr id="12" name="TextBox 11"/>
           <p:cNvSpPr txBox="1"/>
           <p:nvPr/>
         </p:nvSpPr>
         <p:spPr>
           <a:xfrm>
-            <a:off x="1508760" y="2889503"/>
-            <a:ext cx="9628632" cy="786384"/>
+            <a:off x="1508760" y="2834639"/>
+            <a:ext cx="9628632" cy="731520"/>
           </a:xfrm>
           <a:prstGeom prst="rect">
             <a:avLst/>
@@ -6666,13 +6834,13 @@
       </p:sp>
       <p:sp>
         <p:nvSpPr>
-          <p:cNvPr id="11" name="Rounded Rectangle 10"/>
+          <p:cNvPr id="13" name="Rounded Rectangle 12"/>
           <p:cNvSpPr/>
           <p:nvPr/>
         </p:nvSpPr>
         <p:spPr>
           <a:xfrm>
-            <a:off x="1143000" y="3995927"/>
+            <a:off x="1143000" y="3858768"/>
             <a:ext cx="146304" cy="146304"/>
           </a:xfrm>
           <a:prstGeom prst="roundRect">
@@ -6712,14 +6880,14 @@
       </p:sp>
       <p:sp>
         <p:nvSpPr>
-          <p:cNvPr id="12" name="TextBox 11"/>
+          <p:cNvPr id="14" name="TextBox 13"/>
           <p:cNvSpPr txBox="1"/>
           <p:nvPr/>
         </p:nvSpPr>
         <p:spPr>
           <a:xfrm>
-            <a:off x="1508760" y="3675887"/>
-            <a:ext cx="9628632" cy="786384"/>
+            <a:off x="1508760" y="3566160"/>
+            <a:ext cx="9628632" cy="731520"/>
           </a:xfrm>
           <a:prstGeom prst="rect">
             <a:avLst/>
@@ -6747,13 +6915,13 @@
       </p:sp>
       <p:sp>
         <p:nvSpPr>
-          <p:cNvPr id="13" name="Rounded Rectangle 12"/>
+          <p:cNvPr id="15" name="Rounded Rectangle 14"/>
           <p:cNvSpPr/>
           <p:nvPr/>
         </p:nvSpPr>
         <p:spPr>
           <a:xfrm>
-            <a:off x="1143000" y="4782312"/>
+            <a:off x="1143000" y="4590288"/>
             <a:ext cx="146304" cy="146304"/>
           </a:xfrm>
           <a:prstGeom prst="roundRect">
@@ -6793,14 +6961,14 @@
       </p:sp>
       <p:sp>
         <p:nvSpPr>
-          <p:cNvPr id="14" name="TextBox 13"/>
+          <p:cNvPr id="16" name="TextBox 15"/>
           <p:cNvSpPr txBox="1"/>
           <p:nvPr/>
         </p:nvSpPr>
         <p:spPr>
           <a:xfrm>
-            <a:off x="1508760" y="4462272"/>
-            <a:ext cx="9628632" cy="786384"/>
+            <a:off x="1508760" y="4297680"/>
+            <a:ext cx="9628632" cy="731520"/>
           </a:xfrm>
           <a:prstGeom prst="rect">
             <a:avLst/>
@@ -6828,13 +6996,13 @@
       </p:sp>
       <p:sp>
         <p:nvSpPr>
-          <p:cNvPr id="15" name="Rounded Rectangle 14"/>
+          <p:cNvPr id="17" name="Rounded Rectangle 16"/>
           <p:cNvSpPr/>
           <p:nvPr/>
         </p:nvSpPr>
         <p:spPr>
           <a:xfrm>
-            <a:off x="1143000" y="5568696"/>
+            <a:off x="1143000" y="5321808"/>
             <a:ext cx="146304" cy="146304"/>
           </a:xfrm>
           <a:prstGeom prst="roundRect">
@@ -6874,14 +7042,14 @@
       </p:sp>
       <p:sp>
         <p:nvSpPr>
-          <p:cNvPr id="16" name="TextBox 15"/>
+          <p:cNvPr id="18" name="TextBox 17"/>
           <p:cNvSpPr txBox="1"/>
           <p:nvPr/>
         </p:nvSpPr>
         <p:spPr>
           <a:xfrm>
-            <a:off x="1508760" y="5248656"/>
-            <a:ext cx="9628632" cy="786384"/>
+            <a:off x="1508760" y="5029200"/>
+            <a:ext cx="9628632" cy="731520"/>
           </a:xfrm>
           <a:prstGeom prst="rect">
             <a:avLst/>
@@ -7014,9 +7182,57 @@
           </a:p>
         </p:txBody>
       </p:sp>
-      <p:sp>
-        <p:nvSpPr>
-          <p:cNvPr id="4" name="Rounded Rectangle 3"/>
+      <p:pic>
+        <p:nvPicPr>
+          <p:cNvPr id="4" name="Picture 3" descr="syncjournal-hex.png"/>
+          <p:cNvPicPr>
+            <a:picLocks noChangeAspect="1"/>
+          </p:cNvPicPr>
+          <p:nvPr/>
+        </p:nvPicPr>
+        <p:blipFill>
+          <a:blip r:embed="rId2"/>
+          <a:stretch>
+            <a:fillRect/>
+          </a:stretch>
+        </p:blipFill>
+        <p:spPr>
+          <a:xfrm>
+            <a:off x="10259568" y="6382512"/>
+            <a:ext cx="347472" cy="347472"/>
+          </a:xfrm>
+          <a:prstGeom prst="rect">
+            <a:avLst/>
+          </a:prstGeom>
+        </p:spPr>
+      </p:pic>
+      <p:pic>
+        <p:nvPicPr>
+          <p:cNvPr id="5" name="Picture 4" descr="morani-badge.png"/>
+          <p:cNvPicPr>
+            <a:picLocks noChangeAspect="1"/>
+          </p:cNvPicPr>
+          <p:nvPr/>
+        </p:nvPicPr>
+        <p:blipFill>
+          <a:blip r:embed="rId3"/>
+          <a:stretch>
+            <a:fillRect/>
+          </a:stretch>
+        </p:blipFill>
+        <p:spPr>
+          <a:xfrm>
+            <a:off x="10698480" y="6400800"/>
+            <a:ext cx="799447" cy="310896"/>
+          </a:xfrm>
+          <a:prstGeom prst="rect">
+            <a:avLst/>
+          </a:prstGeom>
+        </p:spPr>
+      </p:pic>
+      <p:sp>
+        <p:nvSpPr>
+          <p:cNvPr id="6" name="Rounded Rectangle 5"/>
           <p:cNvSpPr/>
           <p:nvPr/>
         </p:nvSpPr>
@@ -7062,7 +7278,7 @@
       </p:sp>
       <p:sp>
         <p:nvSpPr>
-          <p:cNvPr id="5" name="TextBox 4"/>
+          <p:cNvPr id="7" name="TextBox 6"/>
           <p:cNvSpPr txBox="1"/>
           <p:nvPr/>
         </p:nvSpPr>
@@ -7097,14 +7313,14 @@
       </p:sp>
       <p:sp>
         <p:nvSpPr>
-          <p:cNvPr id="6" name="Rounded Rectangle 5"/>
+          <p:cNvPr id="8" name="Rounded Rectangle 7"/>
           <p:cNvSpPr/>
           <p:nvPr/>
         </p:nvSpPr>
         <p:spPr>
           <a:xfrm>
             <a:off x="731520" y="1874519"/>
-            <a:ext cx="10725912" cy="4389120"/>
+            <a:ext cx="10725912" cy="4114800"/>
           </a:xfrm>
           <a:prstGeom prst="roundRect">
             <a:avLst>
@@ -7145,13 +7361,13 @@
       </p:sp>
       <p:sp>
         <p:nvSpPr>
-          <p:cNvPr id="7" name="Rounded Rectangle 6"/>
+          <p:cNvPr id="9" name="Rounded Rectangle 8"/>
           <p:cNvSpPr/>
           <p:nvPr/>
         </p:nvSpPr>
         <p:spPr>
           <a:xfrm>
-            <a:off x="1143000" y="2423160"/>
+            <a:off x="1143000" y="2395727"/>
             <a:ext cx="146304" cy="146304"/>
           </a:xfrm>
           <a:prstGeom prst="roundRect">
@@ -7191,14 +7407,14 @@
       </p:sp>
       <p:sp>
         <p:nvSpPr>
-          <p:cNvPr id="8" name="TextBox 7"/>
+          <p:cNvPr id="10" name="TextBox 9"/>
           <p:cNvSpPr txBox="1"/>
           <p:nvPr/>
         </p:nvSpPr>
         <p:spPr>
           <a:xfrm>
             <a:off x="1508760" y="2103120"/>
-            <a:ext cx="9628632" cy="786384"/>
+            <a:ext cx="9628632" cy="731520"/>
           </a:xfrm>
           <a:prstGeom prst="rect">
             <a:avLst/>
@@ -7226,13 +7442,13 @@
       </p:sp>
       <p:sp>
         <p:nvSpPr>
-          <p:cNvPr id="9" name="Rounded Rectangle 8"/>
+          <p:cNvPr id="11" name="Rounded Rectangle 10"/>
           <p:cNvSpPr/>
           <p:nvPr/>
         </p:nvSpPr>
         <p:spPr>
           <a:xfrm>
-            <a:off x="1143000" y="3209544"/>
+            <a:off x="1143000" y="3127247"/>
             <a:ext cx="146304" cy="146304"/>
           </a:xfrm>
           <a:prstGeom prst="roundRect">
@@ -7272,14 +7488,14 @@
       </p:sp>
       <p:sp>
         <p:nvSpPr>
-          <p:cNvPr id="10" name="TextBox 9"/>
+          <p:cNvPr id="12" name="TextBox 11"/>
           <p:cNvSpPr txBox="1"/>
           <p:nvPr/>
         </p:nvSpPr>
         <p:spPr>
           <a:xfrm>
-            <a:off x="1508760" y="2889503"/>
-            <a:ext cx="9628632" cy="786384"/>
+            <a:off x="1508760" y="2834639"/>
+            <a:ext cx="9628632" cy="731520"/>
           </a:xfrm>
           <a:prstGeom prst="rect">
             <a:avLst/>
@@ -7307,13 +7523,13 @@
       </p:sp>
       <p:sp>
         <p:nvSpPr>
-          <p:cNvPr id="11" name="Rounded Rectangle 10"/>
+          <p:cNvPr id="13" name="Rounded Rectangle 12"/>
           <p:cNvSpPr/>
           <p:nvPr/>
         </p:nvSpPr>
         <p:spPr>
           <a:xfrm>
-            <a:off x="1143000" y="3995927"/>
+            <a:off x="1143000" y="3858768"/>
             <a:ext cx="146304" cy="146304"/>
           </a:xfrm>
           <a:prstGeom prst="roundRect">
@@ -7353,14 +7569,14 @@
       </p:sp>
       <p:sp>
         <p:nvSpPr>
-          <p:cNvPr id="12" name="TextBox 11"/>
+          <p:cNvPr id="14" name="TextBox 13"/>
           <p:cNvSpPr txBox="1"/>
           <p:nvPr/>
         </p:nvSpPr>
         <p:spPr>
           <a:xfrm>
-            <a:off x="1508760" y="3675887"/>
-            <a:ext cx="9628632" cy="786384"/>
+            <a:off x="1508760" y="3566160"/>
+            <a:ext cx="9628632" cy="731520"/>
           </a:xfrm>
           <a:prstGeom prst="rect">
             <a:avLst/>
@@ -7388,13 +7604,13 @@
       </p:sp>
       <p:sp>
         <p:nvSpPr>
-          <p:cNvPr id="13" name="Rounded Rectangle 12"/>
+          <p:cNvPr id="15" name="Rounded Rectangle 14"/>
           <p:cNvSpPr/>
           <p:nvPr/>
         </p:nvSpPr>
         <p:spPr>
           <a:xfrm>
-            <a:off x="1143000" y="4782312"/>
+            <a:off x="1143000" y="4590288"/>
             <a:ext cx="146304" cy="146304"/>
           </a:xfrm>
           <a:prstGeom prst="roundRect">
@@ -7434,14 +7650,14 @@
       </p:sp>
       <p:sp>
         <p:nvSpPr>
-          <p:cNvPr id="14" name="TextBox 13"/>
+          <p:cNvPr id="16" name="TextBox 15"/>
           <p:cNvSpPr txBox="1"/>
           <p:nvPr/>
         </p:nvSpPr>
         <p:spPr>
           <a:xfrm>
-            <a:off x="1508760" y="4462272"/>
-            <a:ext cx="9628632" cy="786384"/>
+            <a:off x="1508760" y="4297680"/>
+            <a:ext cx="9628632" cy="731520"/>
           </a:xfrm>
           <a:prstGeom prst="rect">
             <a:avLst/>
@@ -7469,13 +7685,13 @@
       </p:sp>
       <p:sp>
         <p:nvSpPr>
-          <p:cNvPr id="15" name="Rounded Rectangle 14"/>
+          <p:cNvPr id="17" name="Rounded Rectangle 16"/>
           <p:cNvSpPr/>
           <p:nvPr/>
         </p:nvSpPr>
         <p:spPr>
           <a:xfrm>
-            <a:off x="1143000" y="5568696"/>
+            <a:off x="1143000" y="5321808"/>
             <a:ext cx="146304" cy="146304"/>
           </a:xfrm>
           <a:prstGeom prst="roundRect">
@@ -7515,14 +7731,14 @@
       </p:sp>
       <p:sp>
         <p:nvSpPr>
-          <p:cNvPr id="16" name="TextBox 15"/>
+          <p:cNvPr id="18" name="TextBox 17"/>
           <p:cNvSpPr txBox="1"/>
           <p:nvPr/>
         </p:nvSpPr>
         <p:spPr>
           <a:xfrm>
-            <a:off x="1508760" y="5248656"/>
-            <a:ext cx="9628632" cy="786384"/>
+            <a:off x="1508760" y="5029200"/>
+            <a:ext cx="9628632" cy="731520"/>
           </a:xfrm>
           <a:prstGeom prst="rect">
             <a:avLst/>
@@ -7655,9 +7871,57 @@
           </a:p>
         </p:txBody>
       </p:sp>
-      <p:sp>
-        <p:nvSpPr>
-          <p:cNvPr id="4" name="Rounded Rectangle 3"/>
+      <p:pic>
+        <p:nvPicPr>
+          <p:cNvPr id="4" name="Picture 3" descr="syncjournal-hex.png"/>
+          <p:cNvPicPr>
+            <a:picLocks noChangeAspect="1"/>
+          </p:cNvPicPr>
+          <p:nvPr/>
+        </p:nvPicPr>
+        <p:blipFill>
+          <a:blip r:embed="rId2"/>
+          <a:stretch>
+            <a:fillRect/>
+          </a:stretch>
+        </p:blipFill>
+        <p:spPr>
+          <a:xfrm>
+            <a:off x="10259568" y="6382512"/>
+            <a:ext cx="347472" cy="347472"/>
+          </a:xfrm>
+          <a:prstGeom prst="rect">
+            <a:avLst/>
+          </a:prstGeom>
+        </p:spPr>
+      </p:pic>
+      <p:pic>
+        <p:nvPicPr>
+          <p:cNvPr id="5" name="Picture 4" descr="morani-badge.png"/>
+          <p:cNvPicPr>
+            <a:picLocks noChangeAspect="1"/>
+          </p:cNvPicPr>
+          <p:nvPr/>
+        </p:nvPicPr>
+        <p:blipFill>
+          <a:blip r:embed="rId3"/>
+          <a:stretch>
+            <a:fillRect/>
+          </a:stretch>
+        </p:blipFill>
+        <p:spPr>
+          <a:xfrm>
+            <a:off x="10698480" y="6400800"/>
+            <a:ext cx="799447" cy="310896"/>
+          </a:xfrm>
+          <a:prstGeom prst="rect">
+            <a:avLst/>
+          </a:prstGeom>
+        </p:spPr>
+      </p:pic>
+      <p:sp>
+        <p:nvSpPr>
+          <p:cNvPr id="6" name="Rounded Rectangle 5"/>
           <p:cNvSpPr/>
           <p:nvPr/>
         </p:nvSpPr>
@@ -7703,7 +7967,7 @@
       </p:sp>
       <p:sp>
         <p:nvSpPr>
-          <p:cNvPr id="5" name="TextBox 4"/>
+          <p:cNvPr id="7" name="TextBox 6"/>
           <p:cNvSpPr txBox="1"/>
           <p:nvPr/>
         </p:nvSpPr>
@@ -7738,14 +8002,14 @@
       </p:sp>
       <p:sp>
         <p:nvSpPr>
-          <p:cNvPr id="6" name="Rounded Rectangle 5"/>
+          <p:cNvPr id="8" name="Rounded Rectangle 7"/>
           <p:cNvSpPr/>
           <p:nvPr/>
         </p:nvSpPr>
         <p:spPr>
           <a:xfrm>
             <a:off x="731520" y="1874519"/>
-            <a:ext cx="10725912" cy="4389120"/>
+            <a:ext cx="10725912" cy="4114800"/>
           </a:xfrm>
           <a:prstGeom prst="roundRect">
             <a:avLst>
@@ -7786,13 +8050,13 @@
       </p:sp>
       <p:sp>
         <p:nvSpPr>
-          <p:cNvPr id="7" name="Rounded Rectangle 6"/>
+          <p:cNvPr id="9" name="Rounded Rectangle 8"/>
           <p:cNvSpPr/>
           <p:nvPr/>
         </p:nvSpPr>
         <p:spPr>
           <a:xfrm>
-            <a:off x="1143000" y="2423160"/>
+            <a:off x="1143000" y="2395727"/>
             <a:ext cx="146304" cy="146304"/>
           </a:xfrm>
           <a:prstGeom prst="roundRect">
@@ -7832,14 +8096,14 @@
       </p:sp>
       <p:sp>
         <p:nvSpPr>
-          <p:cNvPr id="8" name="TextBox 7"/>
+          <p:cNvPr id="10" name="TextBox 9"/>
           <p:cNvSpPr txBox="1"/>
           <p:nvPr/>
         </p:nvSpPr>
         <p:spPr>
           <a:xfrm>
             <a:off x="1508760" y="2103120"/>
-            <a:ext cx="9628632" cy="786384"/>
+            <a:ext cx="9628632" cy="731520"/>
           </a:xfrm>
           <a:prstGeom prst="rect">
             <a:avLst/>
@@ -7867,13 +8131,13 @@
       </p:sp>
       <p:sp>
         <p:nvSpPr>
-          <p:cNvPr id="9" name="Rounded Rectangle 8"/>
+          <p:cNvPr id="11" name="Rounded Rectangle 10"/>
           <p:cNvSpPr/>
           <p:nvPr/>
         </p:nvSpPr>
         <p:spPr>
           <a:xfrm>
-            <a:off x="1143000" y="3209544"/>
+            <a:off x="1143000" y="3127247"/>
             <a:ext cx="146304" cy="146304"/>
           </a:xfrm>
           <a:prstGeom prst="roundRect">
@@ -7913,14 +8177,14 @@
       </p:sp>
       <p:sp>
         <p:nvSpPr>
-          <p:cNvPr id="10" name="TextBox 9"/>
+          <p:cNvPr id="12" name="TextBox 11"/>
           <p:cNvSpPr txBox="1"/>
           <p:nvPr/>
         </p:nvSpPr>
         <p:spPr>
           <a:xfrm>
-            <a:off x="1508760" y="2889503"/>
-            <a:ext cx="9628632" cy="786384"/>
+            <a:off x="1508760" y="2834639"/>
+            <a:ext cx="9628632" cy="731520"/>
           </a:xfrm>
           <a:prstGeom prst="rect">
             <a:avLst/>
@@ -7948,13 +8212,13 @@
       </p:sp>
       <p:sp>
         <p:nvSpPr>
-          <p:cNvPr id="11" name="Rounded Rectangle 10"/>
+          <p:cNvPr id="13" name="Rounded Rectangle 12"/>
           <p:cNvSpPr/>
           <p:nvPr/>
         </p:nvSpPr>
         <p:spPr>
           <a:xfrm>
-            <a:off x="1143000" y="3995927"/>
+            <a:off x="1143000" y="3858768"/>
             <a:ext cx="146304" cy="146304"/>
           </a:xfrm>
           <a:prstGeom prst="roundRect">
@@ -7994,14 +8258,14 @@
       </p:sp>
       <p:sp>
         <p:nvSpPr>
-          <p:cNvPr id="12" name="TextBox 11"/>
+          <p:cNvPr id="14" name="TextBox 13"/>
           <p:cNvSpPr txBox="1"/>
           <p:nvPr/>
         </p:nvSpPr>
         <p:spPr>
           <a:xfrm>
-            <a:off x="1508760" y="3675887"/>
-            <a:ext cx="9628632" cy="786384"/>
+            <a:off x="1508760" y="3566160"/>
+            <a:ext cx="9628632" cy="731520"/>
           </a:xfrm>
           <a:prstGeom prst="rect">
             <a:avLst/>
@@ -8029,13 +8293,13 @@
       </p:sp>
       <p:sp>
         <p:nvSpPr>
-          <p:cNvPr id="13" name="Rounded Rectangle 12"/>
+          <p:cNvPr id="15" name="Rounded Rectangle 14"/>
           <p:cNvSpPr/>
           <p:nvPr/>
         </p:nvSpPr>
         <p:spPr>
           <a:xfrm>
-            <a:off x="1143000" y="4782312"/>
+            <a:off x="1143000" y="4590288"/>
             <a:ext cx="146304" cy="146304"/>
           </a:xfrm>
           <a:prstGeom prst="roundRect">
@@ -8075,14 +8339,14 @@
       </p:sp>
       <p:sp>
         <p:nvSpPr>
-          <p:cNvPr id="14" name="TextBox 13"/>
+          <p:cNvPr id="16" name="TextBox 15"/>
           <p:cNvSpPr txBox="1"/>
           <p:nvPr/>
         </p:nvSpPr>
         <p:spPr>
           <a:xfrm>
-            <a:off x="1508760" y="4462272"/>
-            <a:ext cx="9628632" cy="786384"/>
+            <a:off x="1508760" y="4297680"/>
+            <a:ext cx="9628632" cy="731520"/>
           </a:xfrm>
           <a:prstGeom prst="rect">
             <a:avLst/>
@@ -8110,13 +8374,13 @@
       </p:sp>
       <p:sp>
         <p:nvSpPr>
-          <p:cNvPr id="15" name="Rounded Rectangle 14"/>
+          <p:cNvPr id="17" name="Rounded Rectangle 16"/>
           <p:cNvSpPr/>
           <p:nvPr/>
         </p:nvSpPr>
         <p:spPr>
           <a:xfrm>
-            <a:off x="1143000" y="5568696"/>
+            <a:off x="1143000" y="5321808"/>
             <a:ext cx="146304" cy="146304"/>
           </a:xfrm>
           <a:prstGeom prst="roundRect">
@@ -8156,14 +8420,14 @@
       </p:sp>
       <p:sp>
         <p:nvSpPr>
-          <p:cNvPr id="16" name="TextBox 15"/>
+          <p:cNvPr id="18" name="TextBox 17"/>
           <p:cNvSpPr txBox="1"/>
           <p:nvPr/>
         </p:nvSpPr>
         <p:spPr>
           <a:xfrm>
-            <a:off x="1508760" y="5248656"/>
-            <a:ext cx="9628632" cy="786384"/>
+            <a:off x="1508760" y="5029200"/>
+            <a:ext cx="9628632" cy="731520"/>
           </a:xfrm>
           <a:prstGeom prst="rect">
             <a:avLst/>
@@ -8296,9 +8560,57 @@
           </a:p>
         </p:txBody>
       </p:sp>
-      <p:sp>
-        <p:nvSpPr>
-          <p:cNvPr id="4" name="Rounded Rectangle 3"/>
+      <p:pic>
+        <p:nvPicPr>
+          <p:cNvPr id="4" name="Picture 3" descr="syncjournal-hex.png"/>
+          <p:cNvPicPr>
+            <a:picLocks noChangeAspect="1"/>
+          </p:cNvPicPr>
+          <p:nvPr/>
+        </p:nvPicPr>
+        <p:blipFill>
+          <a:blip r:embed="rId2"/>
+          <a:stretch>
+            <a:fillRect/>
+          </a:stretch>
+        </p:blipFill>
+        <p:spPr>
+          <a:xfrm>
+            <a:off x="10259568" y="6382512"/>
+            <a:ext cx="347472" cy="347472"/>
+          </a:xfrm>
+          <a:prstGeom prst="rect">
+            <a:avLst/>
+          </a:prstGeom>
+        </p:spPr>
+      </p:pic>
+      <p:pic>
+        <p:nvPicPr>
+          <p:cNvPr id="5" name="Picture 4" descr="morani-badge.png"/>
+          <p:cNvPicPr>
+            <a:picLocks noChangeAspect="1"/>
+          </p:cNvPicPr>
+          <p:nvPr/>
+        </p:nvPicPr>
+        <p:blipFill>
+          <a:blip r:embed="rId3"/>
+          <a:stretch>
+            <a:fillRect/>
+          </a:stretch>
+        </p:blipFill>
+        <p:spPr>
+          <a:xfrm>
+            <a:off x="10698480" y="6400800"/>
+            <a:ext cx="799447" cy="310896"/>
+          </a:xfrm>
+          <a:prstGeom prst="rect">
+            <a:avLst/>
+          </a:prstGeom>
+        </p:spPr>
+      </p:pic>
+      <p:sp>
+        <p:nvSpPr>
+          <p:cNvPr id="6" name="Rounded Rectangle 5"/>
           <p:cNvSpPr/>
           <p:nvPr/>
         </p:nvSpPr>
@@ -8346,7 +8658,7 @@
       </p:sp>
       <p:sp>
         <p:nvSpPr>
-          <p:cNvPr id="5" name="Rectangle 4"/>
+          <p:cNvPr id="7" name="Rectangle 6"/>
           <p:cNvSpPr/>
           <p:nvPr/>
         </p:nvSpPr>
@@ -8390,7 +8702,7 @@
       </p:sp>
       <p:sp>
         <p:nvSpPr>
-          <p:cNvPr id="6" name="TextBox 5"/>
+          <p:cNvPr id="8" name="TextBox 7"/>
           <p:cNvSpPr txBox="1"/>
           <p:nvPr/>
         </p:nvSpPr>
@@ -8425,7 +8737,7 @@
       </p:sp>
       <p:sp>
         <p:nvSpPr>
-          <p:cNvPr id="7" name="Rounded Rectangle 6"/>
+          <p:cNvPr id="9" name="Rounded Rectangle 8"/>
           <p:cNvSpPr/>
           <p:nvPr/>
         </p:nvSpPr>
@@ -8471,7 +8783,7 @@
       </p:sp>
       <p:sp>
         <p:nvSpPr>
-          <p:cNvPr id="8" name="TextBox 7"/>
+          <p:cNvPr id="10" name="TextBox 9"/>
           <p:cNvSpPr txBox="1"/>
           <p:nvPr/>
         </p:nvSpPr>
@@ -8506,7 +8818,7 @@
       </p:sp>
       <p:sp>
         <p:nvSpPr>
-          <p:cNvPr id="9" name="Rounded Rectangle 8"/>
+          <p:cNvPr id="11" name="Rounded Rectangle 10"/>
           <p:cNvSpPr/>
           <p:nvPr/>
         </p:nvSpPr>
@@ -8552,7 +8864,7 @@
       </p:sp>
       <p:sp>
         <p:nvSpPr>
-          <p:cNvPr id="10" name="TextBox 9"/>
+          <p:cNvPr id="12" name="TextBox 11"/>
           <p:cNvSpPr txBox="1"/>
           <p:nvPr/>
         </p:nvSpPr>
@@ -8587,7 +8899,7 @@
       </p:sp>
       <p:sp>
         <p:nvSpPr>
-          <p:cNvPr id="11" name="Rounded Rectangle 10"/>
+          <p:cNvPr id="13" name="Rounded Rectangle 12"/>
           <p:cNvSpPr/>
           <p:nvPr/>
         </p:nvSpPr>
@@ -8633,7 +8945,7 @@
       </p:sp>
       <p:sp>
         <p:nvSpPr>
-          <p:cNvPr id="12" name="TextBox 11"/>
+          <p:cNvPr id="14" name="TextBox 13"/>
           <p:cNvSpPr txBox="1"/>
           <p:nvPr/>
         </p:nvSpPr>
@@ -8668,7 +8980,7 @@
       </p:sp>
       <p:sp>
         <p:nvSpPr>
-          <p:cNvPr id="13" name="Rounded Rectangle 12"/>
+          <p:cNvPr id="15" name="Rounded Rectangle 14"/>
           <p:cNvSpPr/>
           <p:nvPr/>
         </p:nvSpPr>
@@ -8716,7 +9028,7 @@
       </p:sp>
       <p:sp>
         <p:nvSpPr>
-          <p:cNvPr id="14" name="Rectangle 13"/>
+          <p:cNvPr id="16" name="Rectangle 15"/>
           <p:cNvSpPr/>
           <p:nvPr/>
         </p:nvSpPr>
@@ -8760,7 +9072,7 @@
       </p:sp>
       <p:sp>
         <p:nvSpPr>
-          <p:cNvPr id="15" name="TextBox 14"/>
+          <p:cNvPr id="17" name="TextBox 16"/>
           <p:cNvSpPr txBox="1"/>
           <p:nvPr/>
         </p:nvSpPr>
@@ -8795,7 +9107,7 @@
       </p:sp>
       <p:sp>
         <p:nvSpPr>
-          <p:cNvPr id="16" name="Rounded Rectangle 15"/>
+          <p:cNvPr id="18" name="Rounded Rectangle 17"/>
           <p:cNvSpPr/>
           <p:nvPr/>
         </p:nvSpPr>
@@ -8841,7 +9153,7 @@
       </p:sp>
       <p:sp>
         <p:nvSpPr>
-          <p:cNvPr id="17" name="TextBox 16"/>
+          <p:cNvPr id="19" name="TextBox 18"/>
           <p:cNvSpPr txBox="1"/>
           <p:nvPr/>
         </p:nvSpPr>
@@ -8876,7 +9188,7 @@
       </p:sp>
       <p:sp>
         <p:nvSpPr>
-          <p:cNvPr id="18" name="Rounded Rectangle 17"/>
+          <p:cNvPr id="20" name="Rounded Rectangle 19"/>
           <p:cNvSpPr/>
           <p:nvPr/>
         </p:nvSpPr>
@@ -8922,7 +9234,7 @@
       </p:sp>
       <p:sp>
         <p:nvSpPr>
-          <p:cNvPr id="19" name="TextBox 18"/>
+          <p:cNvPr id="21" name="TextBox 20"/>
           <p:cNvSpPr txBox="1"/>
           <p:nvPr/>
         </p:nvSpPr>
@@ -8957,7 +9269,7 @@
       </p:sp>
       <p:sp>
         <p:nvSpPr>
-          <p:cNvPr id="20" name="Rounded Rectangle 19"/>
+          <p:cNvPr id="22" name="Rounded Rectangle 21"/>
           <p:cNvSpPr/>
           <p:nvPr/>
         </p:nvSpPr>
@@ -9003,7 +9315,7 @@
       </p:sp>
       <p:sp>
         <p:nvSpPr>
-          <p:cNvPr id="21" name="TextBox 20"/>
+          <p:cNvPr id="23" name="TextBox 22"/>
           <p:cNvSpPr txBox="1"/>
           <p:nvPr/>
         </p:nvSpPr>
@@ -9038,7 +9350,7 @@
       </p:sp>
       <p:sp>
         <p:nvSpPr>
-          <p:cNvPr id="22" name="Rounded Rectangle 21"/>
+          <p:cNvPr id="24" name="Rounded Rectangle 23"/>
           <p:cNvSpPr/>
           <p:nvPr/>
         </p:nvSpPr>
@@ -9086,7 +9398,7 @@
       </p:sp>
       <p:sp>
         <p:nvSpPr>
-          <p:cNvPr id="23" name="Rectangle 22"/>
+          <p:cNvPr id="25" name="Rectangle 24"/>
           <p:cNvSpPr/>
           <p:nvPr/>
         </p:nvSpPr>
@@ -9130,7 +9442,7 @@
       </p:sp>
       <p:sp>
         <p:nvSpPr>
-          <p:cNvPr id="24" name="TextBox 23"/>
+          <p:cNvPr id="26" name="TextBox 25"/>
           <p:cNvSpPr txBox="1"/>
           <p:nvPr/>
         </p:nvSpPr>
@@ -9165,7 +9477,7 @@
       </p:sp>
       <p:sp>
         <p:nvSpPr>
-          <p:cNvPr id="25" name="Rounded Rectangle 24"/>
+          <p:cNvPr id="27" name="Rounded Rectangle 26"/>
           <p:cNvSpPr/>
           <p:nvPr/>
         </p:nvSpPr>
@@ -9211,7 +9523,7 @@
       </p:sp>
       <p:sp>
         <p:nvSpPr>
-          <p:cNvPr id="26" name="TextBox 25"/>
+          <p:cNvPr id="28" name="TextBox 27"/>
           <p:cNvSpPr txBox="1"/>
           <p:nvPr/>
         </p:nvSpPr>
@@ -9677,7 +9989,7 @@
       </p:sp>
       <p:pic>
         <p:nvPicPr>
-          <p:cNvPr id="13" name="Picture 12" descr="morani-badge.png"/>
+          <p:cNvPr id="13" name="Picture 12" descr="syncjournal-hex.png"/>
           <p:cNvPicPr>
             <a:picLocks noChangeAspect="1"/>
           </p:cNvPicPr>
@@ -9685,6 +9997,30 @@
         </p:nvPicPr>
         <p:blipFill>
           <a:blip r:embed="rId2"/>
+          <a:stretch>
+            <a:fillRect/>
+          </a:stretch>
+        </p:blipFill>
+        <p:spPr>
+          <a:xfrm>
+            <a:off x="8549640" y="5440680"/>
+            <a:ext cx="786384" cy="786384"/>
+          </a:xfrm>
+          <a:prstGeom prst="rect">
+            <a:avLst/>
+          </a:prstGeom>
+        </p:spPr>
+      </p:pic>
+      <p:pic>
+        <p:nvPicPr>
+          <p:cNvPr id="14" name="Picture 13" descr="morani-badge.png"/>
+          <p:cNvPicPr>
+            <a:picLocks noChangeAspect="1"/>
+          </p:cNvPicPr>
+          <p:nvPr/>
+        </p:nvPicPr>
+        <p:blipFill>
+          <a:blip r:embed="rId3"/>
           <a:stretch>
             <a:fillRect/>
           </a:stretch>
@@ -9841,9 +10177,57 @@
           </a:p>
         </p:txBody>
       </p:sp>
-      <p:sp>
-        <p:nvSpPr>
-          <p:cNvPr id="5" name="Rounded Rectangle 4"/>
+      <p:pic>
+        <p:nvPicPr>
+          <p:cNvPr id="5" name="Picture 4" descr="syncjournal-hex.png"/>
+          <p:cNvPicPr>
+            <a:picLocks noChangeAspect="1"/>
+          </p:cNvPicPr>
+          <p:nvPr/>
+        </p:nvPicPr>
+        <p:blipFill>
+          <a:blip r:embed="rId2"/>
+          <a:stretch>
+            <a:fillRect/>
+          </a:stretch>
+        </p:blipFill>
+        <p:spPr>
+          <a:xfrm>
+            <a:off x="10259568" y="6382512"/>
+            <a:ext cx="347472" cy="347472"/>
+          </a:xfrm>
+          <a:prstGeom prst="rect">
+            <a:avLst/>
+          </a:prstGeom>
+        </p:spPr>
+      </p:pic>
+      <p:pic>
+        <p:nvPicPr>
+          <p:cNvPr id="6" name="Picture 5" descr="morani-badge.png"/>
+          <p:cNvPicPr>
+            <a:picLocks noChangeAspect="1"/>
+          </p:cNvPicPr>
+          <p:nvPr/>
+        </p:nvPicPr>
+        <p:blipFill>
+          <a:blip r:embed="rId3"/>
+          <a:stretch>
+            <a:fillRect/>
+          </a:stretch>
+        </p:blipFill>
+        <p:spPr>
+          <a:xfrm>
+            <a:off x="10698480" y="6400800"/>
+            <a:ext cx="799447" cy="310896"/>
+          </a:xfrm>
+          <a:prstGeom prst="rect">
+            <a:avLst/>
+          </a:prstGeom>
+        </p:spPr>
+      </p:pic>
+      <p:sp>
+        <p:nvSpPr>
+          <p:cNvPr id="7" name="Rounded Rectangle 6"/>
           <p:cNvSpPr/>
           <p:nvPr/>
         </p:nvSpPr>
@@ -9891,7 +10275,7 @@
       </p:sp>
       <p:sp>
         <p:nvSpPr>
-          <p:cNvPr id="6" name="Rounded Rectangle 5"/>
+          <p:cNvPr id="8" name="Rounded Rectangle 7"/>
           <p:cNvSpPr/>
           <p:nvPr/>
         </p:nvSpPr>
@@ -9937,7 +10321,7 @@
       </p:sp>
       <p:sp>
         <p:nvSpPr>
-          <p:cNvPr id="7" name="TextBox 6"/>
+          <p:cNvPr id="9" name="TextBox 8"/>
           <p:cNvSpPr txBox="1"/>
           <p:nvPr/>
         </p:nvSpPr>
@@ -9972,7 +10356,7 @@
       </p:sp>
       <p:sp>
         <p:nvSpPr>
-          <p:cNvPr id="8" name="TextBox 7"/>
+          <p:cNvPr id="10" name="TextBox 9"/>
           <p:cNvSpPr txBox="1"/>
           <p:nvPr/>
         </p:nvSpPr>
@@ -10007,7 +10391,7 @@
       </p:sp>
       <p:sp>
         <p:nvSpPr>
-          <p:cNvPr id="9" name="Rounded Rectangle 8"/>
+          <p:cNvPr id="11" name="Rounded Rectangle 10"/>
           <p:cNvSpPr/>
           <p:nvPr/>
         </p:nvSpPr>
@@ -10055,7 +10439,7 @@
       </p:sp>
       <p:sp>
         <p:nvSpPr>
-          <p:cNvPr id="10" name="Rounded Rectangle 9"/>
+          <p:cNvPr id="12" name="Rounded Rectangle 11"/>
           <p:cNvSpPr/>
           <p:nvPr/>
         </p:nvSpPr>
@@ -10101,7 +10485,7 @@
       </p:sp>
       <p:sp>
         <p:nvSpPr>
-          <p:cNvPr id="11" name="TextBox 10"/>
+          <p:cNvPr id="13" name="TextBox 12"/>
           <p:cNvSpPr txBox="1"/>
           <p:nvPr/>
         </p:nvSpPr>
@@ -10136,7 +10520,7 @@
       </p:sp>
       <p:sp>
         <p:nvSpPr>
-          <p:cNvPr id="12" name="TextBox 11"/>
+          <p:cNvPr id="14" name="TextBox 13"/>
           <p:cNvSpPr txBox="1"/>
           <p:nvPr/>
         </p:nvSpPr>
@@ -10171,7 +10555,7 @@
       </p:sp>
       <p:sp>
         <p:nvSpPr>
-          <p:cNvPr id="13" name="Rounded Rectangle 12"/>
+          <p:cNvPr id="15" name="Rounded Rectangle 14"/>
           <p:cNvSpPr/>
           <p:nvPr/>
         </p:nvSpPr>
@@ -10219,7 +10603,7 @@
       </p:sp>
       <p:sp>
         <p:nvSpPr>
-          <p:cNvPr id="14" name="Rounded Rectangle 13"/>
+          <p:cNvPr id="16" name="Rounded Rectangle 15"/>
           <p:cNvSpPr/>
           <p:nvPr/>
         </p:nvSpPr>
@@ -10265,7 +10649,7 @@
       </p:sp>
       <p:sp>
         <p:nvSpPr>
-          <p:cNvPr id="15" name="TextBox 14"/>
+          <p:cNvPr id="17" name="TextBox 16"/>
           <p:cNvSpPr txBox="1"/>
           <p:nvPr/>
         </p:nvSpPr>
@@ -10300,7 +10684,7 @@
       </p:sp>
       <p:sp>
         <p:nvSpPr>
-          <p:cNvPr id="16" name="TextBox 15"/>
+          <p:cNvPr id="18" name="TextBox 17"/>
           <p:cNvSpPr txBox="1"/>
           <p:nvPr/>
         </p:nvSpPr>
@@ -10335,7 +10719,7 @@
       </p:sp>
       <p:sp>
         <p:nvSpPr>
-          <p:cNvPr id="17" name="Rounded Rectangle 16"/>
+          <p:cNvPr id="19" name="Rounded Rectangle 18"/>
           <p:cNvSpPr/>
           <p:nvPr/>
         </p:nvSpPr>
@@ -10383,7 +10767,7 @@
       </p:sp>
       <p:sp>
         <p:nvSpPr>
-          <p:cNvPr id="18" name="Rounded Rectangle 17"/>
+          <p:cNvPr id="20" name="Rounded Rectangle 19"/>
           <p:cNvSpPr/>
           <p:nvPr/>
         </p:nvSpPr>
@@ -10429,7 +10813,7 @@
       </p:sp>
       <p:sp>
         <p:nvSpPr>
-          <p:cNvPr id="19" name="TextBox 18"/>
+          <p:cNvPr id="21" name="TextBox 20"/>
           <p:cNvSpPr txBox="1"/>
           <p:nvPr/>
         </p:nvSpPr>
@@ -10464,7 +10848,7 @@
       </p:sp>
       <p:sp>
         <p:nvSpPr>
-          <p:cNvPr id="20" name="TextBox 19"/>
+          <p:cNvPr id="22" name="TextBox 21"/>
           <p:cNvSpPr txBox="1"/>
           <p:nvPr/>
         </p:nvSpPr>
@@ -10604,9 +10988,57 @@
           </a:p>
         </p:txBody>
       </p:sp>
-      <p:sp>
-        <p:nvSpPr>
-          <p:cNvPr id="4" name="Rounded Rectangle 3"/>
+      <p:pic>
+        <p:nvPicPr>
+          <p:cNvPr id="4" name="Picture 3" descr="syncjournal-hex.png"/>
+          <p:cNvPicPr>
+            <a:picLocks noChangeAspect="1"/>
+          </p:cNvPicPr>
+          <p:nvPr/>
+        </p:nvPicPr>
+        <p:blipFill>
+          <a:blip r:embed="rId2"/>
+          <a:stretch>
+            <a:fillRect/>
+          </a:stretch>
+        </p:blipFill>
+        <p:spPr>
+          <a:xfrm>
+            <a:off x="10259568" y="6382512"/>
+            <a:ext cx="347472" cy="347472"/>
+          </a:xfrm>
+          <a:prstGeom prst="rect">
+            <a:avLst/>
+          </a:prstGeom>
+        </p:spPr>
+      </p:pic>
+      <p:pic>
+        <p:nvPicPr>
+          <p:cNvPr id="5" name="Picture 4" descr="morani-badge.png"/>
+          <p:cNvPicPr>
+            <a:picLocks noChangeAspect="1"/>
+          </p:cNvPicPr>
+          <p:nvPr/>
+        </p:nvPicPr>
+        <p:blipFill>
+          <a:blip r:embed="rId3"/>
+          <a:stretch>
+            <a:fillRect/>
+          </a:stretch>
+        </p:blipFill>
+        <p:spPr>
+          <a:xfrm>
+            <a:off x="10698480" y="6400800"/>
+            <a:ext cx="799447" cy="310896"/>
+          </a:xfrm>
+          <a:prstGeom prst="rect">
+            <a:avLst/>
+          </a:prstGeom>
+        </p:spPr>
+      </p:pic>
+      <p:sp>
+        <p:nvSpPr>
+          <p:cNvPr id="6" name="Rounded Rectangle 5"/>
           <p:cNvSpPr/>
           <p:nvPr/>
         </p:nvSpPr>
@@ -10652,7 +11084,7 @@
       </p:sp>
       <p:sp>
         <p:nvSpPr>
-          <p:cNvPr id="5" name="TextBox 4"/>
+          <p:cNvPr id="7" name="TextBox 6"/>
           <p:cNvSpPr txBox="1"/>
           <p:nvPr/>
         </p:nvSpPr>
@@ -10687,7 +11119,7 @@
       </p:sp>
       <p:sp>
         <p:nvSpPr>
-          <p:cNvPr id="6" name="TextBox 5"/>
+          <p:cNvPr id="8" name="TextBox 7"/>
           <p:cNvSpPr txBox="1"/>
           <p:nvPr/>
         </p:nvSpPr>
@@ -10722,7 +11154,7 @@
       </p:sp>
       <p:sp>
         <p:nvSpPr>
-          <p:cNvPr id="7" name="Rounded Rectangle 6"/>
+          <p:cNvPr id="9" name="Rounded Rectangle 8"/>
           <p:cNvSpPr/>
           <p:nvPr/>
         </p:nvSpPr>
@@ -10768,7 +11200,7 @@
       </p:sp>
       <p:sp>
         <p:nvSpPr>
-          <p:cNvPr id="8" name="TextBox 7"/>
+          <p:cNvPr id="10" name="TextBox 9"/>
           <p:cNvSpPr txBox="1"/>
           <p:nvPr/>
         </p:nvSpPr>
@@ -10803,7 +11235,7 @@
       </p:sp>
       <p:sp>
         <p:nvSpPr>
-          <p:cNvPr id="9" name="Rounded Rectangle 8"/>
+          <p:cNvPr id="11" name="Rounded Rectangle 10"/>
           <p:cNvSpPr/>
           <p:nvPr/>
         </p:nvSpPr>
@@ -10849,7 +11281,7 @@
       </p:sp>
       <p:sp>
         <p:nvSpPr>
-          <p:cNvPr id="10" name="TextBox 9"/>
+          <p:cNvPr id="12" name="TextBox 11"/>
           <p:cNvSpPr txBox="1"/>
           <p:nvPr/>
         </p:nvSpPr>
@@ -10884,7 +11316,7 @@
       </p:sp>
       <p:sp>
         <p:nvSpPr>
-          <p:cNvPr id="11" name="Rounded Rectangle 10"/>
+          <p:cNvPr id="13" name="Rounded Rectangle 12"/>
           <p:cNvSpPr/>
           <p:nvPr/>
         </p:nvSpPr>
@@ -10930,7 +11362,7 @@
       </p:sp>
       <p:sp>
         <p:nvSpPr>
-          <p:cNvPr id="12" name="TextBox 11"/>
+          <p:cNvPr id="14" name="TextBox 13"/>
           <p:cNvSpPr txBox="1"/>
           <p:nvPr/>
         </p:nvSpPr>
@@ -10965,14 +11397,14 @@
       </p:sp>
       <p:pic>
         <p:nvPicPr>
-          <p:cNvPr id="13" name="Picture 12" descr="dashboard-rounded.png"/>
+          <p:cNvPr id="15" name="Picture 14" descr="dashboard-rounded.png"/>
           <p:cNvPicPr>
             <a:picLocks noChangeAspect="1"/>
           </p:cNvPicPr>
           <p:nvPr/>
         </p:nvPicPr>
         <p:blipFill>
-          <a:blip r:embed="rId2"/>
+          <a:blip r:embed="rId4"/>
           <a:stretch>
             <a:fillRect/>
           </a:stretch>
@@ -10989,7 +11421,7 @@
       </p:pic>
       <p:sp>
         <p:nvSpPr>
-          <p:cNvPr id="14" name="TextBox 13"/>
+          <p:cNvPr id="16" name="TextBox 15"/>
           <p:cNvSpPr txBox="1"/>
           <p:nvPr/>
         </p:nvSpPr>
@@ -11129,16 +11561,64 @@
           </a:p>
         </p:txBody>
       </p:sp>
-      <p:sp>
-        <p:nvSpPr>
-          <p:cNvPr id="4" name="Rounded Rectangle 3"/>
+      <p:pic>
+        <p:nvPicPr>
+          <p:cNvPr id="4" name="Picture 3" descr="syncjournal-hex.png"/>
+          <p:cNvPicPr>
+            <a:picLocks noChangeAspect="1"/>
+          </p:cNvPicPr>
+          <p:nvPr/>
+        </p:nvPicPr>
+        <p:blipFill>
+          <a:blip r:embed="rId2"/>
+          <a:stretch>
+            <a:fillRect/>
+          </a:stretch>
+        </p:blipFill>
+        <p:spPr>
+          <a:xfrm>
+            <a:off x="10259568" y="6382512"/>
+            <a:ext cx="347472" cy="347472"/>
+          </a:xfrm>
+          <a:prstGeom prst="rect">
+            <a:avLst/>
+          </a:prstGeom>
+        </p:spPr>
+      </p:pic>
+      <p:pic>
+        <p:nvPicPr>
+          <p:cNvPr id="5" name="Picture 4" descr="morani-badge.png"/>
+          <p:cNvPicPr>
+            <a:picLocks noChangeAspect="1"/>
+          </p:cNvPicPr>
+          <p:nvPr/>
+        </p:nvPicPr>
+        <p:blipFill>
+          <a:blip r:embed="rId3"/>
+          <a:stretch>
+            <a:fillRect/>
+          </a:stretch>
+        </p:blipFill>
+        <p:spPr>
+          <a:xfrm>
+            <a:off x="10698480" y="6400800"/>
+            <a:ext cx="799447" cy="310896"/>
+          </a:xfrm>
+          <a:prstGeom prst="rect">
+            <a:avLst/>
+          </a:prstGeom>
+        </p:spPr>
+      </p:pic>
+      <p:sp>
+        <p:nvSpPr>
+          <p:cNvPr id="6" name="Rounded Rectangle 5"/>
           <p:cNvSpPr/>
           <p:nvPr/>
         </p:nvSpPr>
         <p:spPr>
           <a:xfrm>
             <a:off x="731520" y="1874519"/>
-            <a:ext cx="10725912" cy="4389120"/>
+            <a:ext cx="10725912" cy="4114800"/>
           </a:xfrm>
           <a:prstGeom prst="roundRect">
             <a:avLst>
@@ -11179,13 +11659,13 @@
       </p:sp>
       <p:sp>
         <p:nvSpPr>
-          <p:cNvPr id="5" name="Rounded Rectangle 4"/>
+          <p:cNvPr id="7" name="Rounded Rectangle 6"/>
           <p:cNvSpPr/>
           <p:nvPr/>
         </p:nvSpPr>
         <p:spPr>
           <a:xfrm>
-            <a:off x="1143000" y="2423160"/>
+            <a:off x="1143000" y="2395727"/>
             <a:ext cx="146304" cy="146304"/>
           </a:xfrm>
           <a:prstGeom prst="roundRect">
@@ -11225,14 +11705,14 @@
       </p:sp>
       <p:sp>
         <p:nvSpPr>
-          <p:cNvPr id="6" name="TextBox 5"/>
+          <p:cNvPr id="8" name="TextBox 7"/>
           <p:cNvSpPr txBox="1"/>
           <p:nvPr/>
         </p:nvSpPr>
         <p:spPr>
           <a:xfrm>
             <a:off x="1508760" y="2103120"/>
-            <a:ext cx="9628632" cy="786384"/>
+            <a:ext cx="9628632" cy="731520"/>
           </a:xfrm>
           <a:prstGeom prst="rect">
             <a:avLst/>
@@ -11260,13 +11740,13 @@
       </p:sp>
       <p:sp>
         <p:nvSpPr>
-          <p:cNvPr id="7" name="Rounded Rectangle 6"/>
+          <p:cNvPr id="9" name="Rounded Rectangle 8"/>
           <p:cNvSpPr/>
           <p:nvPr/>
         </p:nvSpPr>
         <p:spPr>
           <a:xfrm>
-            <a:off x="1143000" y="3209544"/>
+            <a:off x="1143000" y="3127247"/>
             <a:ext cx="146304" cy="146304"/>
           </a:xfrm>
           <a:prstGeom prst="roundRect">
@@ -11306,14 +11786,14 @@
       </p:sp>
       <p:sp>
         <p:nvSpPr>
-          <p:cNvPr id="8" name="TextBox 7"/>
+          <p:cNvPr id="10" name="TextBox 9"/>
           <p:cNvSpPr txBox="1"/>
           <p:nvPr/>
         </p:nvSpPr>
         <p:spPr>
           <a:xfrm>
-            <a:off x="1508760" y="2889503"/>
-            <a:ext cx="9628632" cy="786384"/>
+            <a:off x="1508760" y="2834639"/>
+            <a:ext cx="9628632" cy="731520"/>
           </a:xfrm>
           <a:prstGeom prst="rect">
             <a:avLst/>
@@ -11341,13 +11821,13 @@
       </p:sp>
       <p:sp>
         <p:nvSpPr>
-          <p:cNvPr id="9" name="Rounded Rectangle 8"/>
+          <p:cNvPr id="11" name="Rounded Rectangle 10"/>
           <p:cNvSpPr/>
           <p:nvPr/>
         </p:nvSpPr>
         <p:spPr>
           <a:xfrm>
-            <a:off x="1143000" y="3995927"/>
+            <a:off x="1143000" y="3858768"/>
             <a:ext cx="146304" cy="146304"/>
           </a:xfrm>
           <a:prstGeom prst="roundRect">
@@ -11387,14 +11867,14 @@
       </p:sp>
       <p:sp>
         <p:nvSpPr>
-          <p:cNvPr id="10" name="TextBox 9"/>
+          <p:cNvPr id="12" name="TextBox 11"/>
           <p:cNvSpPr txBox="1"/>
           <p:nvPr/>
         </p:nvSpPr>
         <p:spPr>
           <a:xfrm>
-            <a:off x="1508760" y="3675887"/>
-            <a:ext cx="9628632" cy="786384"/>
+            <a:off x="1508760" y="3566160"/>
+            <a:ext cx="9628632" cy="731520"/>
           </a:xfrm>
           <a:prstGeom prst="rect">
             <a:avLst/>
@@ -11422,13 +11902,13 @@
       </p:sp>
       <p:sp>
         <p:nvSpPr>
-          <p:cNvPr id="11" name="Rounded Rectangle 10"/>
+          <p:cNvPr id="13" name="Rounded Rectangle 12"/>
           <p:cNvSpPr/>
           <p:nvPr/>
         </p:nvSpPr>
         <p:spPr>
           <a:xfrm>
-            <a:off x="1143000" y="4782312"/>
+            <a:off x="1143000" y="4590288"/>
             <a:ext cx="146304" cy="146304"/>
           </a:xfrm>
           <a:prstGeom prst="roundRect">
@@ -11468,14 +11948,14 @@
       </p:sp>
       <p:sp>
         <p:nvSpPr>
-          <p:cNvPr id="12" name="TextBox 11"/>
+          <p:cNvPr id="14" name="TextBox 13"/>
           <p:cNvSpPr txBox="1"/>
           <p:nvPr/>
         </p:nvSpPr>
         <p:spPr>
           <a:xfrm>
-            <a:off x="1508760" y="4462272"/>
-            <a:ext cx="9628632" cy="786384"/>
+            <a:off x="1508760" y="4297680"/>
+            <a:ext cx="9628632" cy="731520"/>
           </a:xfrm>
           <a:prstGeom prst="rect">
             <a:avLst/>
@@ -11503,13 +11983,13 @@
       </p:sp>
       <p:sp>
         <p:nvSpPr>
-          <p:cNvPr id="13" name="Rounded Rectangle 12"/>
+          <p:cNvPr id="15" name="Rounded Rectangle 14"/>
           <p:cNvSpPr/>
           <p:nvPr/>
         </p:nvSpPr>
         <p:spPr>
           <a:xfrm>
-            <a:off x="1143000" y="5568696"/>
+            <a:off x="1143000" y="5321808"/>
             <a:ext cx="146304" cy="146304"/>
           </a:xfrm>
           <a:prstGeom prst="roundRect">
@@ -11549,14 +12029,14 @@
       </p:sp>
       <p:sp>
         <p:nvSpPr>
-          <p:cNvPr id="14" name="TextBox 13"/>
+          <p:cNvPr id="16" name="TextBox 15"/>
           <p:cNvSpPr txBox="1"/>
           <p:nvPr/>
         </p:nvSpPr>
         <p:spPr>
           <a:xfrm>
-            <a:off x="1508760" y="5248656"/>
-            <a:ext cx="9628632" cy="786384"/>
+            <a:off x="1508760" y="5029200"/>
+            <a:ext cx="9628632" cy="731520"/>
           </a:xfrm>
           <a:prstGeom prst="rect">
             <a:avLst/>
@@ -11724,9 +12204,57 @@
           </a:p>
         </p:txBody>
       </p:sp>
-      <p:sp>
-        <p:nvSpPr>
-          <p:cNvPr id="5" name="Rounded Rectangle 4"/>
+      <p:pic>
+        <p:nvPicPr>
+          <p:cNvPr id="5" name="Picture 4" descr="syncjournal-hex.png"/>
+          <p:cNvPicPr>
+            <a:picLocks noChangeAspect="1"/>
+          </p:cNvPicPr>
+          <p:nvPr/>
+        </p:nvPicPr>
+        <p:blipFill>
+          <a:blip r:embed="rId2"/>
+          <a:stretch>
+            <a:fillRect/>
+          </a:stretch>
+        </p:blipFill>
+        <p:spPr>
+          <a:xfrm>
+            <a:off x="10259568" y="6382512"/>
+            <a:ext cx="347472" cy="347472"/>
+          </a:xfrm>
+          <a:prstGeom prst="rect">
+            <a:avLst/>
+          </a:prstGeom>
+        </p:spPr>
+      </p:pic>
+      <p:pic>
+        <p:nvPicPr>
+          <p:cNvPr id="6" name="Picture 5" descr="morani-badge.png"/>
+          <p:cNvPicPr>
+            <a:picLocks noChangeAspect="1"/>
+          </p:cNvPicPr>
+          <p:nvPr/>
+        </p:nvPicPr>
+        <p:blipFill>
+          <a:blip r:embed="rId3"/>
+          <a:stretch>
+            <a:fillRect/>
+          </a:stretch>
+        </p:blipFill>
+        <p:spPr>
+          <a:xfrm>
+            <a:off x="10698480" y="6400800"/>
+            <a:ext cx="799447" cy="310896"/>
+          </a:xfrm>
+          <a:prstGeom prst="rect">
+            <a:avLst/>
+          </a:prstGeom>
+        </p:spPr>
+      </p:pic>
+      <p:sp>
+        <p:nvSpPr>
+          <p:cNvPr id="7" name="Rounded Rectangle 6"/>
           <p:cNvSpPr/>
           <p:nvPr/>
         </p:nvSpPr>
@@ -11772,7 +12300,7 @@
       </p:sp>
       <p:sp>
         <p:nvSpPr>
-          <p:cNvPr id="6" name="TextBox 5"/>
+          <p:cNvPr id="8" name="TextBox 7"/>
           <p:cNvSpPr txBox="1"/>
           <p:nvPr/>
         </p:nvSpPr>
@@ -11807,14 +12335,14 @@
       </p:sp>
       <p:sp>
         <p:nvSpPr>
-          <p:cNvPr id="7" name="Rounded Rectangle 6"/>
+          <p:cNvPr id="9" name="Rounded Rectangle 8"/>
           <p:cNvSpPr/>
           <p:nvPr/>
         </p:nvSpPr>
         <p:spPr>
           <a:xfrm>
             <a:off x="731520" y="1828800"/>
-            <a:ext cx="10725912" cy="4480560"/>
+            <a:ext cx="10725912" cy="4251960"/>
           </a:xfrm>
           <a:prstGeom prst="roundRect">
             <a:avLst>
@@ -11855,7 +12383,7 @@
       </p:sp>
       <p:sp>
         <p:nvSpPr>
-          <p:cNvPr id="8" name="TextBox 7"/>
+          <p:cNvPr id="10" name="TextBox 9"/>
           <p:cNvSpPr txBox="1"/>
           <p:nvPr/>
         </p:nvSpPr>
@@ -11890,7 +12418,7 @@
       </p:sp>
       <p:sp>
         <p:nvSpPr>
-          <p:cNvPr id="9" name="Rounded Rectangle 8"/>
+          <p:cNvPr id="11" name="Rounded Rectangle 10"/>
           <p:cNvSpPr/>
           <p:nvPr/>
         </p:nvSpPr>
@@ -11938,7 +12466,7 @@
       </p:sp>
       <p:sp>
         <p:nvSpPr>
-          <p:cNvPr id="10" name="TextBox 9"/>
+          <p:cNvPr id="12" name="TextBox 11"/>
           <p:cNvSpPr txBox="1"/>
           <p:nvPr/>
         </p:nvSpPr>
@@ -11973,7 +12501,7 @@
       </p:sp>
       <p:sp>
         <p:nvSpPr>
-          <p:cNvPr id="11" name="Rounded Rectangle 10"/>
+          <p:cNvPr id="13" name="Rounded Rectangle 12"/>
           <p:cNvSpPr/>
           <p:nvPr/>
         </p:nvSpPr>
@@ -12021,7 +12549,7 @@
       </p:sp>
       <p:sp>
         <p:nvSpPr>
-          <p:cNvPr id="12" name="TextBox 11"/>
+          <p:cNvPr id="14" name="TextBox 13"/>
           <p:cNvSpPr txBox="1"/>
           <p:nvPr/>
         </p:nvSpPr>
@@ -12056,7 +12584,7 @@
       </p:sp>
       <p:sp>
         <p:nvSpPr>
-          <p:cNvPr id="13" name="Rounded Rectangle 12"/>
+          <p:cNvPr id="15" name="Rounded Rectangle 14"/>
           <p:cNvSpPr/>
           <p:nvPr/>
         </p:nvSpPr>
@@ -12104,7 +12632,7 @@
       </p:sp>
       <p:sp>
         <p:nvSpPr>
-          <p:cNvPr id="14" name="TextBox 13"/>
+          <p:cNvPr id="16" name="TextBox 15"/>
           <p:cNvSpPr txBox="1"/>
           <p:nvPr/>
         </p:nvSpPr>
@@ -12139,7 +12667,7 @@
       </p:sp>
       <p:sp>
         <p:nvSpPr>
-          <p:cNvPr id="15" name="TextBox 14"/>
+          <p:cNvPr id="17" name="TextBox 16"/>
           <p:cNvSpPr txBox="1"/>
           <p:nvPr/>
         </p:nvSpPr>
@@ -12174,13 +12702,13 @@
       </p:sp>
       <p:sp>
         <p:nvSpPr>
-          <p:cNvPr id="16" name="TextBox 15"/>
+          <p:cNvPr id="18" name="TextBox 17"/>
           <p:cNvSpPr txBox="1"/>
           <p:nvPr/>
         </p:nvSpPr>
         <p:spPr>
           <a:xfrm>
-            <a:off x="1097280" y="2834640"/>
+            <a:off x="1097280" y="2788920"/>
             <a:ext cx="548640" cy="822960"/>
           </a:xfrm>
           <a:prstGeom prst="rect">
@@ -12209,13 +12737,13 @@
       </p:sp>
       <p:sp>
         <p:nvSpPr>
-          <p:cNvPr id="17" name="Rounded Rectangle 16"/>
+          <p:cNvPr id="19" name="Rounded Rectangle 18"/>
           <p:cNvSpPr/>
           <p:nvPr/>
         </p:nvSpPr>
         <p:spPr>
           <a:xfrm>
-            <a:off x="1645920" y="2990088"/>
+            <a:off x="1645920" y="2944368"/>
             <a:ext cx="1568196" cy="512064"/>
           </a:xfrm>
           <a:prstGeom prst="roundRect">
@@ -12257,13 +12785,13 @@
       </p:sp>
       <p:sp>
         <p:nvSpPr>
-          <p:cNvPr id="18" name="TextBox 17"/>
+          <p:cNvPr id="20" name="TextBox 19"/>
           <p:cNvSpPr txBox="1"/>
           <p:nvPr/>
         </p:nvSpPr>
         <p:spPr>
           <a:xfrm>
-            <a:off x="1645920" y="2990088"/>
+            <a:off x="1645920" y="2944368"/>
             <a:ext cx="1568196" cy="512064"/>
           </a:xfrm>
           <a:prstGeom prst="rect">
@@ -12292,13 +12820,13 @@
       </p:sp>
       <p:sp>
         <p:nvSpPr>
-          <p:cNvPr id="19" name="Rounded Rectangle 18"/>
+          <p:cNvPr id="21" name="Rounded Rectangle 20"/>
           <p:cNvSpPr/>
           <p:nvPr/>
         </p:nvSpPr>
         <p:spPr>
           <a:xfrm>
-            <a:off x="3378708" y="2990088"/>
+            <a:off x="3378708" y="2944368"/>
             <a:ext cx="1709928" cy="512064"/>
           </a:xfrm>
           <a:prstGeom prst="roundRect">
@@ -12340,13 +12868,13 @@
       </p:sp>
       <p:sp>
         <p:nvSpPr>
-          <p:cNvPr id="20" name="TextBox 19"/>
+          <p:cNvPr id="22" name="TextBox 21"/>
           <p:cNvSpPr txBox="1"/>
           <p:nvPr/>
         </p:nvSpPr>
         <p:spPr>
           <a:xfrm>
-            <a:off x="3378708" y="2990088"/>
+            <a:off x="3378708" y="2944368"/>
             <a:ext cx="1709928" cy="512064"/>
           </a:xfrm>
           <a:prstGeom prst="rect">
@@ -12375,13 +12903,13 @@
       </p:sp>
       <p:sp>
         <p:nvSpPr>
-          <p:cNvPr id="21" name="TextBox 20"/>
+          <p:cNvPr id="23" name="TextBox 22"/>
           <p:cNvSpPr txBox="1"/>
           <p:nvPr/>
         </p:nvSpPr>
         <p:spPr>
           <a:xfrm>
-            <a:off x="6949440" y="2834640"/>
+            <a:off x="6949440" y="2788920"/>
             <a:ext cx="4297680" cy="822960"/>
           </a:xfrm>
           <a:prstGeom prst="rect">
@@ -12410,13 +12938,13 @@
       </p:sp>
       <p:sp>
         <p:nvSpPr>
-          <p:cNvPr id="22" name="TextBox 21"/>
+          <p:cNvPr id="24" name="TextBox 23"/>
           <p:cNvSpPr txBox="1"/>
           <p:nvPr/>
         </p:nvSpPr>
         <p:spPr>
           <a:xfrm>
-            <a:off x="1097280" y="3657600"/>
+            <a:off x="1097280" y="3566160"/>
             <a:ext cx="548640" cy="822960"/>
           </a:xfrm>
           <a:prstGeom prst="rect">
@@ -12445,13 +12973,13 @@
       </p:sp>
       <p:sp>
         <p:nvSpPr>
-          <p:cNvPr id="23" name="Rounded Rectangle 22"/>
+          <p:cNvPr id="25" name="Rounded Rectangle 24"/>
           <p:cNvSpPr/>
           <p:nvPr/>
         </p:nvSpPr>
         <p:spPr>
           <a:xfrm>
-            <a:off x="1645920" y="3813048"/>
+            <a:off x="1645920" y="3721608"/>
             <a:ext cx="1426464" cy="512064"/>
           </a:xfrm>
           <a:prstGeom prst="roundRect">
@@ -12493,13 +13021,13 @@
       </p:sp>
       <p:sp>
         <p:nvSpPr>
-          <p:cNvPr id="24" name="TextBox 23"/>
+          <p:cNvPr id="26" name="TextBox 25"/>
           <p:cNvSpPr txBox="1"/>
           <p:nvPr/>
         </p:nvSpPr>
         <p:spPr>
           <a:xfrm>
-            <a:off x="1645920" y="3813048"/>
+            <a:off x="1645920" y="3721608"/>
             <a:ext cx="1426464" cy="512064"/>
           </a:xfrm>
           <a:prstGeom prst="rect">
@@ -12528,13 +13056,13 @@
       </p:sp>
       <p:sp>
         <p:nvSpPr>
-          <p:cNvPr id="25" name="Rounded Rectangle 24"/>
+          <p:cNvPr id="27" name="Rounded Rectangle 26"/>
           <p:cNvSpPr/>
           <p:nvPr/>
         </p:nvSpPr>
         <p:spPr>
           <a:xfrm>
-            <a:off x="3236976" y="3813048"/>
+            <a:off x="3236976" y="3721608"/>
             <a:ext cx="1143000" cy="512064"/>
           </a:xfrm>
           <a:prstGeom prst="roundRect">
@@ -12576,13 +13104,13 @@
       </p:sp>
       <p:sp>
         <p:nvSpPr>
-          <p:cNvPr id="26" name="TextBox 25"/>
+          <p:cNvPr id="28" name="TextBox 27"/>
           <p:cNvSpPr txBox="1"/>
           <p:nvPr/>
         </p:nvSpPr>
         <p:spPr>
           <a:xfrm>
-            <a:off x="3236976" y="3813048"/>
+            <a:off x="3236976" y="3721608"/>
             <a:ext cx="1143000" cy="512064"/>
           </a:xfrm>
           <a:prstGeom prst="rect">
@@ -12611,13 +13139,13 @@
       </p:sp>
       <p:sp>
         <p:nvSpPr>
-          <p:cNvPr id="27" name="TextBox 26"/>
+          <p:cNvPr id="29" name="TextBox 28"/>
           <p:cNvSpPr txBox="1"/>
           <p:nvPr/>
         </p:nvSpPr>
         <p:spPr>
           <a:xfrm>
-            <a:off x="6949440" y="3657600"/>
+            <a:off x="6949440" y="3566160"/>
             <a:ext cx="4297680" cy="822960"/>
           </a:xfrm>
           <a:prstGeom prst="rect">
@@ -12646,13 +13174,13 @@
       </p:sp>
       <p:sp>
         <p:nvSpPr>
-          <p:cNvPr id="28" name="TextBox 27"/>
+          <p:cNvPr id="30" name="TextBox 29"/>
           <p:cNvSpPr txBox="1"/>
           <p:nvPr/>
         </p:nvSpPr>
         <p:spPr>
           <a:xfrm>
-            <a:off x="1097280" y="4480560"/>
+            <a:off x="1097280" y="4343400"/>
             <a:ext cx="548640" cy="822960"/>
           </a:xfrm>
           <a:prstGeom prst="rect">
@@ -12681,13 +13209,13 @@
       </p:sp>
       <p:sp>
         <p:nvSpPr>
-          <p:cNvPr id="29" name="Rounded Rectangle 28"/>
+          <p:cNvPr id="31" name="Rounded Rectangle 30"/>
           <p:cNvSpPr/>
           <p:nvPr/>
         </p:nvSpPr>
         <p:spPr>
           <a:xfrm>
-            <a:off x="1645920" y="4636008"/>
+            <a:off x="1645920" y="4498848"/>
             <a:ext cx="859536" cy="512064"/>
           </a:xfrm>
           <a:prstGeom prst="roundRect">
@@ -12729,13 +13257,13 @@
       </p:sp>
       <p:sp>
         <p:nvSpPr>
-          <p:cNvPr id="30" name="TextBox 29"/>
+          <p:cNvPr id="32" name="TextBox 31"/>
           <p:cNvSpPr txBox="1"/>
           <p:nvPr/>
         </p:nvSpPr>
         <p:spPr>
           <a:xfrm>
-            <a:off x="1645920" y="4636008"/>
+            <a:off x="1645920" y="4498848"/>
             <a:ext cx="859536" cy="512064"/>
           </a:xfrm>
           <a:prstGeom prst="rect">
@@ -12764,13 +13292,13 @@
       </p:sp>
       <p:sp>
         <p:nvSpPr>
-          <p:cNvPr id="31" name="TextBox 30"/>
+          <p:cNvPr id="33" name="TextBox 32"/>
           <p:cNvSpPr txBox="1"/>
           <p:nvPr/>
         </p:nvSpPr>
         <p:spPr>
           <a:xfrm>
-            <a:off x="6949440" y="4480560"/>
+            <a:off x="6949440" y="4343400"/>
             <a:ext cx="4297680" cy="822960"/>
           </a:xfrm>
           <a:prstGeom prst="rect">
@@ -12799,13 +13327,13 @@
       </p:sp>
       <p:sp>
         <p:nvSpPr>
-          <p:cNvPr id="32" name="TextBox 31"/>
+          <p:cNvPr id="34" name="TextBox 33"/>
           <p:cNvSpPr txBox="1"/>
           <p:nvPr/>
         </p:nvSpPr>
         <p:spPr>
           <a:xfrm>
-            <a:off x="1097280" y="5303520"/>
+            <a:off x="1097280" y="5120640"/>
             <a:ext cx="548640" cy="822960"/>
           </a:xfrm>
           <a:prstGeom prst="rect">
@@ -12834,13 +13362,13 @@
       </p:sp>
       <p:sp>
         <p:nvSpPr>
-          <p:cNvPr id="33" name="Rounded Rectangle 32"/>
+          <p:cNvPr id="35" name="Rounded Rectangle 34"/>
           <p:cNvSpPr/>
           <p:nvPr/>
         </p:nvSpPr>
         <p:spPr>
           <a:xfrm>
-            <a:off x="1645920" y="5458968"/>
+            <a:off x="1645920" y="5276088"/>
             <a:ext cx="717803" cy="512064"/>
           </a:xfrm>
           <a:prstGeom prst="roundRect">
@@ -12882,13 +13410,13 @@
       </p:sp>
       <p:sp>
         <p:nvSpPr>
-          <p:cNvPr id="34" name="TextBox 33"/>
+          <p:cNvPr id="36" name="TextBox 35"/>
           <p:cNvSpPr txBox="1"/>
           <p:nvPr/>
         </p:nvSpPr>
         <p:spPr>
           <a:xfrm>
-            <a:off x="1645920" y="5458968"/>
+            <a:off x="1645920" y="5276088"/>
             <a:ext cx="717803" cy="512064"/>
           </a:xfrm>
           <a:prstGeom prst="rect">
@@ -12917,13 +13445,13 @@
       </p:sp>
       <p:sp>
         <p:nvSpPr>
-          <p:cNvPr id="35" name="Rounded Rectangle 34"/>
+          <p:cNvPr id="37" name="Rounded Rectangle 36"/>
           <p:cNvSpPr/>
           <p:nvPr/>
         </p:nvSpPr>
         <p:spPr>
           <a:xfrm>
-            <a:off x="2528315" y="5458968"/>
+            <a:off x="2528315" y="5276088"/>
             <a:ext cx="1426464" cy="512064"/>
           </a:xfrm>
           <a:prstGeom prst="roundRect">
@@ -12965,13 +13493,13 @@
       </p:sp>
       <p:sp>
         <p:nvSpPr>
-          <p:cNvPr id="36" name="TextBox 35"/>
+          <p:cNvPr id="38" name="TextBox 37"/>
           <p:cNvSpPr txBox="1"/>
           <p:nvPr/>
         </p:nvSpPr>
         <p:spPr>
           <a:xfrm>
-            <a:off x="2528315" y="5458968"/>
+            <a:off x="2528315" y="5276088"/>
             <a:ext cx="1426464" cy="512064"/>
           </a:xfrm>
           <a:prstGeom prst="rect">
@@ -13000,13 +13528,13 @@
       </p:sp>
       <p:sp>
         <p:nvSpPr>
-          <p:cNvPr id="37" name="TextBox 36"/>
+          <p:cNvPr id="39" name="TextBox 38"/>
           <p:cNvSpPr txBox="1"/>
           <p:nvPr/>
         </p:nvSpPr>
         <p:spPr>
           <a:xfrm>
-            <a:off x="6949440" y="5303520"/>
+            <a:off x="6949440" y="5120640"/>
             <a:ext cx="4297680" cy="822960"/>
           </a:xfrm>
           <a:prstGeom prst="rect">
@@ -13175,9 +13703,57 @@
           </a:p>
         </p:txBody>
       </p:sp>
-      <p:sp>
-        <p:nvSpPr>
-          <p:cNvPr id="5" name="Rounded Rectangle 4"/>
+      <p:pic>
+        <p:nvPicPr>
+          <p:cNvPr id="5" name="Picture 4" descr="syncjournal-hex.png"/>
+          <p:cNvPicPr>
+            <a:picLocks noChangeAspect="1"/>
+          </p:cNvPicPr>
+          <p:nvPr/>
+        </p:nvPicPr>
+        <p:blipFill>
+          <a:blip r:embed="rId2"/>
+          <a:stretch>
+            <a:fillRect/>
+          </a:stretch>
+        </p:blipFill>
+        <p:spPr>
+          <a:xfrm>
+            <a:off x="10259568" y="6382512"/>
+            <a:ext cx="347472" cy="347472"/>
+          </a:xfrm>
+          <a:prstGeom prst="rect">
+            <a:avLst/>
+          </a:prstGeom>
+        </p:spPr>
+      </p:pic>
+      <p:pic>
+        <p:nvPicPr>
+          <p:cNvPr id="6" name="Picture 5" descr="morani-badge.png"/>
+          <p:cNvPicPr>
+            <a:picLocks noChangeAspect="1"/>
+          </p:cNvPicPr>
+          <p:nvPr/>
+        </p:nvPicPr>
+        <p:blipFill>
+          <a:blip r:embed="rId3"/>
+          <a:stretch>
+            <a:fillRect/>
+          </a:stretch>
+        </p:blipFill>
+        <p:spPr>
+          <a:xfrm>
+            <a:off x="10698480" y="6400800"/>
+            <a:ext cx="799447" cy="310896"/>
+          </a:xfrm>
+          <a:prstGeom prst="rect">
+            <a:avLst/>
+          </a:prstGeom>
+        </p:spPr>
+      </p:pic>
+      <p:sp>
+        <p:nvSpPr>
+          <p:cNvPr id="7" name="Rounded Rectangle 6"/>
           <p:cNvSpPr/>
           <p:nvPr/>
         </p:nvSpPr>
@@ -13223,7 +13799,7 @@
       </p:sp>
       <p:sp>
         <p:nvSpPr>
-          <p:cNvPr id="6" name="TextBox 5"/>
+          <p:cNvPr id="8" name="TextBox 7"/>
           <p:cNvSpPr txBox="1"/>
           <p:nvPr/>
         </p:nvSpPr>
@@ -13258,14 +13834,14 @@
       </p:sp>
       <p:sp>
         <p:nvSpPr>
-          <p:cNvPr id="7" name="Rounded Rectangle 6"/>
+          <p:cNvPr id="9" name="Rounded Rectangle 8"/>
           <p:cNvSpPr/>
           <p:nvPr/>
         </p:nvSpPr>
         <p:spPr>
           <a:xfrm>
             <a:off x="731520" y="1828800"/>
-            <a:ext cx="10725912" cy="4480560"/>
+            <a:ext cx="10725912" cy="4251960"/>
           </a:xfrm>
           <a:prstGeom prst="roundRect">
             <a:avLst>
@@ -13306,7 +13882,7 @@
       </p:sp>
       <p:sp>
         <p:nvSpPr>
-          <p:cNvPr id="8" name="TextBox 7"/>
+          <p:cNvPr id="10" name="TextBox 9"/>
           <p:cNvSpPr txBox="1"/>
           <p:nvPr/>
         </p:nvSpPr>
@@ -13341,7 +13917,7 @@
       </p:sp>
       <p:sp>
         <p:nvSpPr>
-          <p:cNvPr id="9" name="Rounded Rectangle 8"/>
+          <p:cNvPr id="11" name="Rounded Rectangle 10"/>
           <p:cNvSpPr/>
           <p:nvPr/>
         </p:nvSpPr>
@@ -13389,7 +13965,7 @@
       </p:sp>
       <p:sp>
         <p:nvSpPr>
-          <p:cNvPr id="10" name="TextBox 9"/>
+          <p:cNvPr id="12" name="TextBox 11"/>
           <p:cNvSpPr txBox="1"/>
           <p:nvPr/>
         </p:nvSpPr>
@@ -13424,7 +14000,7 @@
       </p:sp>
       <p:sp>
         <p:nvSpPr>
-          <p:cNvPr id="11" name="TextBox 10"/>
+          <p:cNvPr id="13" name="TextBox 12"/>
           <p:cNvSpPr txBox="1"/>
           <p:nvPr/>
         </p:nvSpPr>
@@ -13459,13 +14035,13 @@
       </p:sp>
       <p:sp>
         <p:nvSpPr>
-          <p:cNvPr id="12" name="TextBox 11"/>
+          <p:cNvPr id="14" name="TextBox 13"/>
           <p:cNvSpPr txBox="1"/>
           <p:nvPr/>
         </p:nvSpPr>
         <p:spPr>
           <a:xfrm>
-            <a:off x="1097280" y="2834640"/>
+            <a:off x="1097280" y="2788920"/>
             <a:ext cx="548640" cy="822960"/>
           </a:xfrm>
           <a:prstGeom prst="rect">
@@ -13494,13 +14070,13 @@
       </p:sp>
       <p:sp>
         <p:nvSpPr>
-          <p:cNvPr id="13" name="Rounded Rectangle 12"/>
+          <p:cNvPr id="15" name="Rounded Rectangle 14"/>
           <p:cNvSpPr/>
           <p:nvPr/>
         </p:nvSpPr>
         <p:spPr>
           <a:xfrm>
-            <a:off x="1645920" y="2990088"/>
+            <a:off x="1645920" y="2944368"/>
             <a:ext cx="1426464" cy="512064"/>
           </a:xfrm>
           <a:prstGeom prst="roundRect">
@@ -13542,13 +14118,13 @@
       </p:sp>
       <p:sp>
         <p:nvSpPr>
-          <p:cNvPr id="14" name="TextBox 13"/>
+          <p:cNvPr id="16" name="TextBox 15"/>
           <p:cNvSpPr txBox="1"/>
           <p:nvPr/>
         </p:nvSpPr>
         <p:spPr>
           <a:xfrm>
-            <a:off x="1645920" y="2990088"/>
+            <a:off x="1645920" y="2944368"/>
             <a:ext cx="1426464" cy="512064"/>
           </a:xfrm>
           <a:prstGeom prst="rect">
@@ -13577,13 +14153,13 @@
       </p:sp>
       <p:sp>
         <p:nvSpPr>
-          <p:cNvPr id="15" name="TextBox 14"/>
+          <p:cNvPr id="17" name="TextBox 16"/>
           <p:cNvSpPr txBox="1"/>
           <p:nvPr/>
         </p:nvSpPr>
         <p:spPr>
           <a:xfrm>
-            <a:off x="6949440" y="2834640"/>
+            <a:off x="6949440" y="2788920"/>
             <a:ext cx="4297680" cy="822960"/>
           </a:xfrm>
           <a:prstGeom prst="rect">
@@ -13612,13 +14188,13 @@
       </p:sp>
       <p:sp>
         <p:nvSpPr>
-          <p:cNvPr id="16" name="TextBox 15"/>
+          <p:cNvPr id="18" name="TextBox 17"/>
           <p:cNvSpPr txBox="1"/>
           <p:nvPr/>
         </p:nvSpPr>
         <p:spPr>
           <a:xfrm>
-            <a:off x="1097280" y="3657600"/>
+            <a:off x="1097280" y="3566160"/>
             <a:ext cx="548640" cy="822960"/>
           </a:xfrm>
           <a:prstGeom prst="rect">
@@ -13647,13 +14223,13 @@
       </p:sp>
       <p:sp>
         <p:nvSpPr>
-          <p:cNvPr id="17" name="Rounded Rectangle 16"/>
+          <p:cNvPr id="19" name="Rounded Rectangle 18"/>
           <p:cNvSpPr/>
           <p:nvPr/>
         </p:nvSpPr>
         <p:spPr>
           <a:xfrm>
-            <a:off x="1645920" y="3813048"/>
+            <a:off x="1645920" y="3721608"/>
             <a:ext cx="859536" cy="512064"/>
           </a:xfrm>
           <a:prstGeom prst="roundRect">
@@ -13695,13 +14271,13 @@
       </p:sp>
       <p:sp>
         <p:nvSpPr>
-          <p:cNvPr id="18" name="TextBox 17"/>
+          <p:cNvPr id="20" name="TextBox 19"/>
           <p:cNvSpPr txBox="1"/>
           <p:nvPr/>
         </p:nvSpPr>
         <p:spPr>
           <a:xfrm>
-            <a:off x="1645920" y="3813048"/>
+            <a:off x="1645920" y="3721608"/>
             <a:ext cx="859536" cy="512064"/>
           </a:xfrm>
           <a:prstGeom prst="rect">
@@ -13730,13 +14306,13 @@
       </p:sp>
       <p:sp>
         <p:nvSpPr>
-          <p:cNvPr id="19" name="TextBox 18"/>
+          <p:cNvPr id="21" name="TextBox 20"/>
           <p:cNvSpPr txBox="1"/>
           <p:nvPr/>
         </p:nvSpPr>
         <p:spPr>
           <a:xfrm>
-            <a:off x="6949440" y="3657600"/>
+            <a:off x="6949440" y="3566160"/>
             <a:ext cx="4297680" cy="822960"/>
           </a:xfrm>
           <a:prstGeom prst="rect">
@@ -13765,13 +14341,13 @@
       </p:sp>
       <p:sp>
         <p:nvSpPr>
-          <p:cNvPr id="20" name="TextBox 19"/>
+          <p:cNvPr id="22" name="TextBox 21"/>
           <p:cNvSpPr txBox="1"/>
           <p:nvPr/>
         </p:nvSpPr>
         <p:spPr>
           <a:xfrm>
-            <a:off x="1097280" y="4480560"/>
+            <a:off x="1097280" y="4343400"/>
             <a:ext cx="548640" cy="822960"/>
           </a:xfrm>
           <a:prstGeom prst="rect">
@@ -13800,13 +14376,13 @@
       </p:sp>
       <p:sp>
         <p:nvSpPr>
-          <p:cNvPr id="21" name="Rounded Rectangle 20"/>
+          <p:cNvPr id="23" name="Rounded Rectangle 22"/>
           <p:cNvSpPr/>
           <p:nvPr/>
         </p:nvSpPr>
         <p:spPr>
           <a:xfrm>
-            <a:off x="1645920" y="4636008"/>
+            <a:off x="1645920" y="4498848"/>
             <a:ext cx="1426464" cy="512064"/>
           </a:xfrm>
           <a:prstGeom prst="roundRect">
@@ -13848,13 +14424,13 @@
       </p:sp>
       <p:sp>
         <p:nvSpPr>
-          <p:cNvPr id="22" name="TextBox 21"/>
+          <p:cNvPr id="24" name="TextBox 23"/>
           <p:cNvSpPr txBox="1"/>
           <p:nvPr/>
         </p:nvSpPr>
         <p:spPr>
           <a:xfrm>
-            <a:off x="1645920" y="4636008"/>
+            <a:off x="1645920" y="4498848"/>
             <a:ext cx="1426464" cy="512064"/>
           </a:xfrm>
           <a:prstGeom prst="rect">
@@ -13883,13 +14459,13 @@
       </p:sp>
       <p:sp>
         <p:nvSpPr>
-          <p:cNvPr id="23" name="TextBox 22"/>
+          <p:cNvPr id="25" name="TextBox 24"/>
           <p:cNvSpPr txBox="1"/>
           <p:nvPr/>
         </p:nvSpPr>
         <p:spPr>
           <a:xfrm>
-            <a:off x="6949440" y="4480560"/>
+            <a:off x="6949440" y="4343400"/>
             <a:ext cx="4297680" cy="822960"/>
           </a:xfrm>
           <a:prstGeom prst="rect">
@@ -13918,13 +14494,13 @@
       </p:sp>
       <p:sp>
         <p:nvSpPr>
-          <p:cNvPr id="24" name="TextBox 23"/>
+          <p:cNvPr id="26" name="TextBox 25"/>
           <p:cNvSpPr txBox="1"/>
           <p:nvPr/>
         </p:nvSpPr>
         <p:spPr>
           <a:xfrm>
-            <a:off x="1097280" y="5303520"/>
+            <a:off x="1097280" y="5120640"/>
             <a:ext cx="548640" cy="822960"/>
           </a:xfrm>
           <a:prstGeom prst="rect">
@@ -13953,13 +14529,13 @@
       </p:sp>
       <p:sp>
         <p:nvSpPr>
-          <p:cNvPr id="25" name="Rounded Rectangle 24"/>
+          <p:cNvPr id="27" name="Rounded Rectangle 26"/>
           <p:cNvSpPr/>
           <p:nvPr/>
         </p:nvSpPr>
         <p:spPr>
           <a:xfrm>
-            <a:off x="1645920" y="5458968"/>
+            <a:off x="1645920" y="5276088"/>
             <a:ext cx="859536" cy="512064"/>
           </a:xfrm>
           <a:prstGeom prst="roundRect">
@@ -14001,13 +14577,13 @@
       </p:sp>
       <p:sp>
         <p:nvSpPr>
-          <p:cNvPr id="26" name="TextBox 25"/>
+          <p:cNvPr id="28" name="TextBox 27"/>
           <p:cNvSpPr txBox="1"/>
           <p:nvPr/>
         </p:nvSpPr>
         <p:spPr>
           <a:xfrm>
-            <a:off x="1645920" y="5458968"/>
+            <a:off x="1645920" y="5276088"/>
             <a:ext cx="859536" cy="512064"/>
           </a:xfrm>
           <a:prstGeom prst="rect">
@@ -14036,13 +14612,13 @@
       </p:sp>
       <p:sp>
         <p:nvSpPr>
-          <p:cNvPr id="27" name="Rounded Rectangle 26"/>
+          <p:cNvPr id="29" name="Rounded Rectangle 28"/>
           <p:cNvSpPr/>
           <p:nvPr/>
         </p:nvSpPr>
         <p:spPr>
           <a:xfrm>
-            <a:off x="2670048" y="5458968"/>
+            <a:off x="2670048" y="5276088"/>
             <a:ext cx="1284732" cy="512064"/>
           </a:xfrm>
           <a:prstGeom prst="roundRect">
@@ -14084,13 +14660,13 @@
       </p:sp>
       <p:sp>
         <p:nvSpPr>
-          <p:cNvPr id="28" name="TextBox 27"/>
+          <p:cNvPr id="30" name="TextBox 29"/>
           <p:cNvSpPr txBox="1"/>
           <p:nvPr/>
         </p:nvSpPr>
         <p:spPr>
           <a:xfrm>
-            <a:off x="2670048" y="5458968"/>
+            <a:off x="2670048" y="5276088"/>
             <a:ext cx="1284732" cy="512064"/>
           </a:xfrm>
           <a:prstGeom prst="rect">
@@ -14119,13 +14695,13 @@
       </p:sp>
       <p:sp>
         <p:nvSpPr>
-          <p:cNvPr id="29" name="TextBox 28"/>
+          <p:cNvPr id="31" name="TextBox 30"/>
           <p:cNvSpPr txBox="1"/>
           <p:nvPr/>
         </p:nvSpPr>
         <p:spPr>
           <a:xfrm>
-            <a:off x="6949440" y="5303520"/>
+            <a:off x="6949440" y="5120640"/>
             <a:ext cx="4297680" cy="822960"/>
           </a:xfrm>
           <a:prstGeom prst="rect">
@@ -14259,9 +14835,57 @@
           </a:p>
         </p:txBody>
       </p:sp>
-      <p:sp>
-        <p:nvSpPr>
-          <p:cNvPr id="4" name="Rounded Rectangle 3"/>
+      <p:pic>
+        <p:nvPicPr>
+          <p:cNvPr id="4" name="Picture 3" descr="syncjournal-hex.png"/>
+          <p:cNvPicPr>
+            <a:picLocks noChangeAspect="1"/>
+          </p:cNvPicPr>
+          <p:nvPr/>
+        </p:nvPicPr>
+        <p:blipFill>
+          <a:blip r:embed="rId2"/>
+          <a:stretch>
+            <a:fillRect/>
+          </a:stretch>
+        </p:blipFill>
+        <p:spPr>
+          <a:xfrm>
+            <a:off x="10259568" y="6382512"/>
+            <a:ext cx="347472" cy="347472"/>
+          </a:xfrm>
+          <a:prstGeom prst="rect">
+            <a:avLst/>
+          </a:prstGeom>
+        </p:spPr>
+      </p:pic>
+      <p:pic>
+        <p:nvPicPr>
+          <p:cNvPr id="5" name="Picture 4" descr="morani-badge.png"/>
+          <p:cNvPicPr>
+            <a:picLocks noChangeAspect="1"/>
+          </p:cNvPicPr>
+          <p:nvPr/>
+        </p:nvPicPr>
+        <p:blipFill>
+          <a:blip r:embed="rId3"/>
+          <a:stretch>
+            <a:fillRect/>
+          </a:stretch>
+        </p:blipFill>
+        <p:spPr>
+          <a:xfrm>
+            <a:off x="10698480" y="6400800"/>
+            <a:ext cx="799447" cy="310896"/>
+          </a:xfrm>
+          <a:prstGeom prst="rect">
+            <a:avLst/>
+          </a:prstGeom>
+        </p:spPr>
+      </p:pic>
+      <p:sp>
+        <p:nvSpPr>
+          <p:cNvPr id="6" name="Rounded Rectangle 5"/>
           <p:cNvSpPr/>
           <p:nvPr/>
         </p:nvSpPr>
@@ -14307,7 +14931,7 @@
       </p:sp>
       <p:sp>
         <p:nvSpPr>
-          <p:cNvPr id="5" name="TextBox 4"/>
+          <p:cNvPr id="7" name="TextBox 6"/>
           <p:cNvSpPr txBox="1"/>
           <p:nvPr/>
         </p:nvSpPr>
@@ -14342,14 +14966,14 @@
       </p:sp>
       <p:sp>
         <p:nvSpPr>
-          <p:cNvPr id="6" name="Rounded Rectangle 5"/>
+          <p:cNvPr id="8" name="Rounded Rectangle 7"/>
           <p:cNvSpPr/>
           <p:nvPr/>
         </p:nvSpPr>
         <p:spPr>
           <a:xfrm>
             <a:off x="731520" y="1874519"/>
-            <a:ext cx="10725912" cy="3602736"/>
+            <a:ext cx="10725912" cy="3383280"/>
           </a:xfrm>
           <a:prstGeom prst="roundRect">
             <a:avLst>
@@ -14390,13 +15014,13 @@
       </p:sp>
       <p:sp>
         <p:nvSpPr>
-          <p:cNvPr id="7" name="Rounded Rectangle 6"/>
+          <p:cNvPr id="9" name="Rounded Rectangle 8"/>
           <p:cNvSpPr/>
           <p:nvPr/>
         </p:nvSpPr>
         <p:spPr>
           <a:xfrm>
-            <a:off x="1143000" y="2423160"/>
+            <a:off x="1143000" y="2395727"/>
             <a:ext cx="146304" cy="146304"/>
           </a:xfrm>
           <a:prstGeom prst="roundRect">
@@ -14436,14 +15060,14 @@
       </p:sp>
       <p:sp>
         <p:nvSpPr>
-          <p:cNvPr id="8" name="TextBox 7"/>
+          <p:cNvPr id="10" name="TextBox 9"/>
           <p:cNvSpPr txBox="1"/>
           <p:nvPr/>
         </p:nvSpPr>
         <p:spPr>
           <a:xfrm>
             <a:off x="1508760" y="2103120"/>
-            <a:ext cx="9628632" cy="786384"/>
+            <a:ext cx="9628632" cy="731520"/>
           </a:xfrm>
           <a:prstGeom prst="rect">
             <a:avLst/>
@@ -14471,13 +15095,13 @@
       </p:sp>
       <p:sp>
         <p:nvSpPr>
-          <p:cNvPr id="9" name="Rounded Rectangle 8"/>
+          <p:cNvPr id="11" name="Rounded Rectangle 10"/>
           <p:cNvSpPr/>
           <p:nvPr/>
         </p:nvSpPr>
         <p:spPr>
           <a:xfrm>
-            <a:off x="1143000" y="3209544"/>
+            <a:off x="1143000" y="3127247"/>
             <a:ext cx="146304" cy="146304"/>
           </a:xfrm>
           <a:prstGeom prst="roundRect">
@@ -14517,14 +15141,14 @@
       </p:sp>
       <p:sp>
         <p:nvSpPr>
-          <p:cNvPr id="10" name="TextBox 9"/>
+          <p:cNvPr id="12" name="TextBox 11"/>
           <p:cNvSpPr txBox="1"/>
           <p:nvPr/>
         </p:nvSpPr>
         <p:spPr>
           <a:xfrm>
-            <a:off x="1508760" y="2889503"/>
-            <a:ext cx="9628632" cy="786384"/>
+            <a:off x="1508760" y="2834639"/>
+            <a:ext cx="9628632" cy="731520"/>
           </a:xfrm>
           <a:prstGeom prst="rect">
             <a:avLst/>
@@ -14552,13 +15176,13 @@
       </p:sp>
       <p:sp>
         <p:nvSpPr>
-          <p:cNvPr id="11" name="Rounded Rectangle 10"/>
+          <p:cNvPr id="13" name="Rounded Rectangle 12"/>
           <p:cNvSpPr/>
           <p:nvPr/>
         </p:nvSpPr>
         <p:spPr>
           <a:xfrm>
-            <a:off x="1143000" y="3995927"/>
+            <a:off x="1143000" y="3858768"/>
             <a:ext cx="146304" cy="146304"/>
           </a:xfrm>
           <a:prstGeom prst="roundRect">
@@ -14598,14 +15222,14 @@
       </p:sp>
       <p:sp>
         <p:nvSpPr>
-          <p:cNvPr id="12" name="TextBox 11"/>
+          <p:cNvPr id="14" name="TextBox 13"/>
           <p:cNvSpPr txBox="1"/>
           <p:nvPr/>
         </p:nvSpPr>
         <p:spPr>
           <a:xfrm>
-            <a:off x="1508760" y="3675887"/>
-            <a:ext cx="9628632" cy="786384"/>
+            <a:off x="1508760" y="3566160"/>
+            <a:ext cx="9628632" cy="731520"/>
           </a:xfrm>
           <a:prstGeom prst="rect">
             <a:avLst/>
@@ -14633,13 +15257,13 @@
       </p:sp>
       <p:sp>
         <p:nvSpPr>
-          <p:cNvPr id="13" name="Rounded Rectangle 12"/>
+          <p:cNvPr id="15" name="Rounded Rectangle 14"/>
           <p:cNvSpPr/>
           <p:nvPr/>
         </p:nvSpPr>
         <p:spPr>
           <a:xfrm>
-            <a:off x="1143000" y="4782312"/>
+            <a:off x="1143000" y="4590288"/>
             <a:ext cx="146304" cy="146304"/>
           </a:xfrm>
           <a:prstGeom prst="roundRect">
@@ -14679,14 +15303,14 @@
       </p:sp>
       <p:sp>
         <p:nvSpPr>
-          <p:cNvPr id="14" name="TextBox 13"/>
+          <p:cNvPr id="16" name="TextBox 15"/>
           <p:cNvSpPr txBox="1"/>
           <p:nvPr/>
         </p:nvSpPr>
         <p:spPr>
           <a:xfrm>
-            <a:off x="1508760" y="4462272"/>
-            <a:ext cx="9628632" cy="786384"/>
+            <a:off x="1508760" y="4297680"/>
+            <a:ext cx="9628632" cy="731520"/>
           </a:xfrm>
           <a:prstGeom prst="rect">
             <a:avLst/>
@@ -14854,9 +15478,57 @@
           </a:p>
         </p:txBody>
       </p:sp>
-      <p:sp>
-        <p:nvSpPr>
-          <p:cNvPr id="5" name="Rounded Rectangle 4"/>
+      <p:pic>
+        <p:nvPicPr>
+          <p:cNvPr id="5" name="Picture 4" descr="syncjournal-hex.png"/>
+          <p:cNvPicPr>
+            <a:picLocks noChangeAspect="1"/>
+          </p:cNvPicPr>
+          <p:nvPr/>
+        </p:nvPicPr>
+        <p:blipFill>
+          <a:blip r:embed="rId2"/>
+          <a:stretch>
+            <a:fillRect/>
+          </a:stretch>
+        </p:blipFill>
+        <p:spPr>
+          <a:xfrm>
+            <a:off x="10259568" y="6382512"/>
+            <a:ext cx="347472" cy="347472"/>
+          </a:xfrm>
+          <a:prstGeom prst="rect">
+            <a:avLst/>
+          </a:prstGeom>
+        </p:spPr>
+      </p:pic>
+      <p:pic>
+        <p:nvPicPr>
+          <p:cNvPr id="6" name="Picture 5" descr="morani-badge.png"/>
+          <p:cNvPicPr>
+            <a:picLocks noChangeAspect="1"/>
+          </p:cNvPicPr>
+          <p:nvPr/>
+        </p:nvPicPr>
+        <p:blipFill>
+          <a:blip r:embed="rId3"/>
+          <a:stretch>
+            <a:fillRect/>
+          </a:stretch>
+        </p:blipFill>
+        <p:spPr>
+          <a:xfrm>
+            <a:off x="10698480" y="6400800"/>
+            <a:ext cx="799447" cy="310896"/>
+          </a:xfrm>
+          <a:prstGeom prst="rect">
+            <a:avLst/>
+          </a:prstGeom>
+        </p:spPr>
+      </p:pic>
+      <p:sp>
+        <p:nvSpPr>
+          <p:cNvPr id="7" name="Rounded Rectangle 6"/>
           <p:cNvSpPr/>
           <p:nvPr/>
         </p:nvSpPr>
@@ -14902,7 +15574,7 @@
       </p:sp>
       <p:sp>
         <p:nvSpPr>
-          <p:cNvPr id="6" name="TextBox 5"/>
+          <p:cNvPr id="8" name="TextBox 7"/>
           <p:cNvSpPr txBox="1"/>
           <p:nvPr/>
         </p:nvSpPr>
@@ -14937,7 +15609,7 @@
       </p:sp>
       <p:sp>
         <p:nvSpPr>
-          <p:cNvPr id="7" name="Rounded Rectangle 6"/>
+          <p:cNvPr id="9" name="Rounded Rectangle 8"/>
           <p:cNvSpPr/>
           <p:nvPr/>
         </p:nvSpPr>
@@ -14985,7 +15657,7 @@
       </p:sp>
       <p:sp>
         <p:nvSpPr>
-          <p:cNvPr id="8" name="Rounded Rectangle 7"/>
+          <p:cNvPr id="10" name="Rounded Rectangle 9"/>
           <p:cNvSpPr/>
           <p:nvPr/>
         </p:nvSpPr>
@@ -15033,7 +15705,7 @@
       </p:sp>
       <p:sp>
         <p:nvSpPr>
-          <p:cNvPr id="9" name="TextBox 8"/>
+          <p:cNvPr id="11" name="TextBox 10"/>
           <p:cNvSpPr txBox="1"/>
           <p:nvPr/>
         </p:nvSpPr>
@@ -15068,7 +15740,7 @@
       </p:sp>
       <p:sp>
         <p:nvSpPr>
-          <p:cNvPr id="10" name="Rounded Rectangle 9"/>
+          <p:cNvPr id="12" name="Rounded Rectangle 11"/>
           <p:cNvSpPr/>
           <p:nvPr/>
         </p:nvSpPr>
@@ -15116,7 +15788,7 @@
       </p:sp>
       <p:sp>
         <p:nvSpPr>
-          <p:cNvPr id="11" name="TextBox 10"/>
+          <p:cNvPr id="13" name="TextBox 12"/>
           <p:cNvSpPr txBox="1"/>
           <p:nvPr/>
         </p:nvSpPr>
@@ -15151,7 +15823,7 @@
       </p:sp>
       <p:sp>
         <p:nvSpPr>
-          <p:cNvPr id="12" name="Rounded Rectangle 11"/>
+          <p:cNvPr id="14" name="Rounded Rectangle 13"/>
           <p:cNvSpPr/>
           <p:nvPr/>
         </p:nvSpPr>
@@ -15199,7 +15871,7 @@
       </p:sp>
       <p:sp>
         <p:nvSpPr>
-          <p:cNvPr id="13" name="TextBox 12"/>
+          <p:cNvPr id="15" name="TextBox 14"/>
           <p:cNvSpPr txBox="1"/>
           <p:nvPr/>
         </p:nvSpPr>
@@ -15234,7 +15906,7 @@
       </p:sp>
       <p:sp>
         <p:nvSpPr>
-          <p:cNvPr id="14" name="Rounded Rectangle 13"/>
+          <p:cNvPr id="16" name="Rounded Rectangle 15"/>
           <p:cNvSpPr/>
           <p:nvPr/>
         </p:nvSpPr>
@@ -15282,7 +15954,7 @@
       </p:sp>
       <p:sp>
         <p:nvSpPr>
-          <p:cNvPr id="15" name="TextBox 14"/>
+          <p:cNvPr id="17" name="TextBox 16"/>
           <p:cNvSpPr txBox="1"/>
           <p:nvPr/>
         </p:nvSpPr>
@@ -15317,7 +15989,7 @@
       </p:sp>
       <p:sp>
         <p:nvSpPr>
-          <p:cNvPr id="16" name="Rounded Rectangle 15"/>
+          <p:cNvPr id="18" name="Rounded Rectangle 17"/>
           <p:cNvSpPr/>
           <p:nvPr/>
         </p:nvSpPr>
@@ -15365,7 +16037,7 @@
       </p:sp>
       <p:sp>
         <p:nvSpPr>
-          <p:cNvPr id="17" name="TextBox 16"/>
+          <p:cNvPr id="19" name="TextBox 18"/>
           <p:cNvSpPr txBox="1"/>
           <p:nvPr/>
         </p:nvSpPr>
@@ -15400,7 +16072,7 @@
       </p:sp>
       <p:sp>
         <p:nvSpPr>
-          <p:cNvPr id="18" name="Rounded Rectangle 17"/>
+          <p:cNvPr id="20" name="Rounded Rectangle 19"/>
           <p:cNvSpPr/>
           <p:nvPr/>
         </p:nvSpPr>
@@ -15448,7 +16120,7 @@
       </p:sp>
       <p:sp>
         <p:nvSpPr>
-          <p:cNvPr id="19" name="TextBox 18"/>
+          <p:cNvPr id="21" name="TextBox 20"/>
           <p:cNvSpPr txBox="1"/>
           <p:nvPr/>
         </p:nvSpPr>
@@ -15483,7 +16155,7 @@
       </p:sp>
       <p:sp>
         <p:nvSpPr>
-          <p:cNvPr id="20" name="Rounded Rectangle 19"/>
+          <p:cNvPr id="22" name="Rounded Rectangle 21"/>
           <p:cNvSpPr/>
           <p:nvPr/>
         </p:nvSpPr>
@@ -15531,7 +16203,7 @@
       </p:sp>
       <p:sp>
         <p:nvSpPr>
-          <p:cNvPr id="21" name="TextBox 20"/>
+          <p:cNvPr id="23" name="TextBox 22"/>
           <p:cNvSpPr txBox="1"/>
           <p:nvPr/>
         </p:nvSpPr>
@@ -15566,7 +16238,7 @@
       </p:sp>
       <p:sp>
         <p:nvSpPr>
-          <p:cNvPr id="22" name="TextBox 21"/>
+          <p:cNvPr id="24" name="TextBox 23"/>
           <p:cNvSpPr txBox="1"/>
           <p:nvPr/>
         </p:nvSpPr>
@@ -15706,9 +16378,57 @@
           </a:p>
         </p:txBody>
       </p:sp>
-      <p:sp>
-        <p:nvSpPr>
-          <p:cNvPr id="4" name="Rounded Rectangle 3"/>
+      <p:pic>
+        <p:nvPicPr>
+          <p:cNvPr id="4" name="Picture 3" descr="syncjournal-hex.png"/>
+          <p:cNvPicPr>
+            <a:picLocks noChangeAspect="1"/>
+          </p:cNvPicPr>
+          <p:nvPr/>
+        </p:nvPicPr>
+        <p:blipFill>
+          <a:blip r:embed="rId2"/>
+          <a:stretch>
+            <a:fillRect/>
+          </a:stretch>
+        </p:blipFill>
+        <p:spPr>
+          <a:xfrm>
+            <a:off x="10259568" y="6382512"/>
+            <a:ext cx="347472" cy="347472"/>
+          </a:xfrm>
+          <a:prstGeom prst="rect">
+            <a:avLst/>
+          </a:prstGeom>
+        </p:spPr>
+      </p:pic>
+      <p:pic>
+        <p:nvPicPr>
+          <p:cNvPr id="5" name="Picture 4" descr="morani-badge.png"/>
+          <p:cNvPicPr>
+            <a:picLocks noChangeAspect="1"/>
+          </p:cNvPicPr>
+          <p:nvPr/>
+        </p:nvPicPr>
+        <p:blipFill>
+          <a:blip r:embed="rId3"/>
+          <a:stretch>
+            <a:fillRect/>
+          </a:stretch>
+        </p:blipFill>
+        <p:spPr>
+          <a:xfrm>
+            <a:off x="10698480" y="6400800"/>
+            <a:ext cx="799447" cy="310896"/>
+          </a:xfrm>
+          <a:prstGeom prst="rect">
+            <a:avLst/>
+          </a:prstGeom>
+        </p:spPr>
+      </p:pic>
+      <p:sp>
+        <p:nvSpPr>
+          <p:cNvPr id="6" name="Rounded Rectangle 5"/>
           <p:cNvSpPr/>
           <p:nvPr/>
         </p:nvSpPr>
@@ -15754,7 +16474,7 @@
       </p:sp>
       <p:sp>
         <p:nvSpPr>
-          <p:cNvPr id="5" name="TextBox 4"/>
+          <p:cNvPr id="7" name="TextBox 6"/>
           <p:cNvSpPr txBox="1"/>
           <p:nvPr/>
         </p:nvSpPr>
@@ -15789,7 +16509,7 @@
       </p:sp>
       <p:sp>
         <p:nvSpPr>
-          <p:cNvPr id="6" name="Rounded Rectangle 5"/>
+          <p:cNvPr id="8" name="Rounded Rectangle 7"/>
           <p:cNvSpPr/>
           <p:nvPr/>
         </p:nvSpPr>
@@ -15837,7 +16557,7 @@
       </p:sp>
       <p:sp>
         <p:nvSpPr>
-          <p:cNvPr id="7" name="Rectangle 6"/>
+          <p:cNvPr id="9" name="Rectangle 8"/>
           <p:cNvSpPr/>
           <p:nvPr/>
         </p:nvSpPr>
@@ -15881,7 +16601,7 @@
       </p:sp>
       <p:sp>
         <p:nvSpPr>
-          <p:cNvPr id="8" name="TextBox 7"/>
+          <p:cNvPr id="10" name="TextBox 9"/>
           <p:cNvSpPr txBox="1"/>
           <p:nvPr/>
         </p:nvSpPr>
@@ -15916,7 +16636,7 @@
       </p:sp>
       <p:sp>
         <p:nvSpPr>
-          <p:cNvPr id="9" name="Rounded Rectangle 8"/>
+          <p:cNvPr id="11" name="Rounded Rectangle 10"/>
           <p:cNvSpPr/>
           <p:nvPr/>
         </p:nvSpPr>
@@ -15962,7 +16682,7 @@
       </p:sp>
       <p:sp>
         <p:nvSpPr>
-          <p:cNvPr id="10" name="TextBox 9"/>
+          <p:cNvPr id="12" name="TextBox 11"/>
           <p:cNvSpPr txBox="1"/>
           <p:nvPr/>
         </p:nvSpPr>
@@ -15997,7 +16717,7 @@
       </p:sp>
       <p:sp>
         <p:nvSpPr>
-          <p:cNvPr id="11" name="Rounded Rectangle 10"/>
+          <p:cNvPr id="13" name="Rounded Rectangle 12"/>
           <p:cNvSpPr/>
           <p:nvPr/>
         </p:nvSpPr>
@@ -16043,7 +16763,7 @@
       </p:sp>
       <p:sp>
         <p:nvSpPr>
-          <p:cNvPr id="12" name="TextBox 11"/>
+          <p:cNvPr id="14" name="TextBox 13"/>
           <p:cNvSpPr txBox="1"/>
           <p:nvPr/>
         </p:nvSpPr>
@@ -16078,7 +16798,7 @@
       </p:sp>
       <p:sp>
         <p:nvSpPr>
-          <p:cNvPr id="13" name="Rounded Rectangle 12"/>
+          <p:cNvPr id="15" name="Rounded Rectangle 14"/>
           <p:cNvSpPr/>
           <p:nvPr/>
         </p:nvSpPr>
@@ -16124,7 +16844,7 @@
       </p:sp>
       <p:sp>
         <p:nvSpPr>
-          <p:cNvPr id="14" name="TextBox 13"/>
+          <p:cNvPr id="16" name="TextBox 15"/>
           <p:cNvSpPr txBox="1"/>
           <p:nvPr/>
         </p:nvSpPr>
@@ -16159,7 +16879,7 @@
       </p:sp>
       <p:sp>
         <p:nvSpPr>
-          <p:cNvPr id="15" name="Rounded Rectangle 14"/>
+          <p:cNvPr id="17" name="Rounded Rectangle 16"/>
           <p:cNvSpPr/>
           <p:nvPr/>
         </p:nvSpPr>
@@ -16207,7 +16927,7 @@
       </p:sp>
       <p:sp>
         <p:nvSpPr>
-          <p:cNvPr id="16" name="Rectangle 15"/>
+          <p:cNvPr id="18" name="Rectangle 17"/>
           <p:cNvSpPr/>
           <p:nvPr/>
         </p:nvSpPr>
@@ -16251,7 +16971,7 @@
       </p:sp>
       <p:sp>
         <p:nvSpPr>
-          <p:cNvPr id="17" name="TextBox 16"/>
+          <p:cNvPr id="19" name="TextBox 18"/>
           <p:cNvSpPr txBox="1"/>
           <p:nvPr/>
         </p:nvSpPr>
@@ -16286,7 +17006,7 @@
       </p:sp>
       <p:sp>
         <p:nvSpPr>
-          <p:cNvPr id="18" name="Rounded Rectangle 17"/>
+          <p:cNvPr id="20" name="Rounded Rectangle 19"/>
           <p:cNvSpPr/>
           <p:nvPr/>
         </p:nvSpPr>
@@ -16332,7 +17052,7 @@
       </p:sp>
       <p:sp>
         <p:nvSpPr>
-          <p:cNvPr id="19" name="TextBox 18"/>
+          <p:cNvPr id="21" name="TextBox 20"/>
           <p:cNvSpPr txBox="1"/>
           <p:nvPr/>
         </p:nvSpPr>
@@ -16367,7 +17087,7 @@
       </p:sp>
       <p:sp>
         <p:nvSpPr>
-          <p:cNvPr id="20" name="Rounded Rectangle 19"/>
+          <p:cNvPr id="22" name="Rounded Rectangle 21"/>
           <p:cNvSpPr/>
           <p:nvPr/>
         </p:nvSpPr>
@@ -16413,7 +17133,7 @@
       </p:sp>
       <p:sp>
         <p:nvSpPr>
-          <p:cNvPr id="21" name="TextBox 20"/>
+          <p:cNvPr id="23" name="TextBox 22"/>
           <p:cNvSpPr txBox="1"/>
           <p:nvPr/>
         </p:nvSpPr>
@@ -16448,7 +17168,7 @@
       </p:sp>
       <p:sp>
         <p:nvSpPr>
-          <p:cNvPr id="22" name="Rounded Rectangle 21"/>
+          <p:cNvPr id="24" name="Rounded Rectangle 23"/>
           <p:cNvSpPr/>
           <p:nvPr/>
         </p:nvSpPr>
@@ -16494,7 +17214,7 @@
       </p:sp>
       <p:sp>
         <p:nvSpPr>
-          <p:cNvPr id="23" name="TextBox 22"/>
+          <p:cNvPr id="25" name="TextBox 24"/>
           <p:cNvSpPr txBox="1"/>
           <p:nvPr/>
         </p:nvSpPr>

</xml_diff>